<commit_message>
Require MySQL and align final docs
</commit_message>
<xml_diff>
--- a/deliverables/Java_모의주식투자_발표자료_최종정합본.pptx
+++ b/deliverables/Java_모의주식투자_발표자료_최종정합본.pptx
@@ -3848,7 +3848,7 @@
         <p:spPr>
           <a:xfrm>
             <a:off x="914400" y="1005840"/>
-            <a:ext cx="2273198" cy="716280"/>
+            <a:ext cx="2273198" cy="613954"/>
           </a:xfrm>
           <a:prstGeom prst="rect">
             <a:avLst/>
@@ -3873,7 +3873,7 @@
         <p:spPr>
           <a:xfrm>
             <a:off x="987552" y="1078992"/>
-            <a:ext cx="2126894" cy="588264"/>
+            <a:ext cx="2126894" cy="485938"/>
           </a:xfrm>
           <a:prstGeom prst="rect">
             <a:avLst/>
@@ -3911,7 +3911,7 @@
         <p:spPr>
           <a:xfrm>
             <a:off x="3187598" y="1005840"/>
-            <a:ext cx="8059522" cy="716280"/>
+            <a:ext cx="8059522" cy="613954"/>
           </a:xfrm>
           <a:prstGeom prst="rect">
             <a:avLst/>
@@ -3936,7 +3936,7 @@
         <p:spPr>
           <a:xfrm>
             <a:off x="3260750" y="1078992"/>
-            <a:ext cx="7913218" cy="588264"/>
+            <a:ext cx="7913218" cy="485938"/>
           </a:xfrm>
           <a:prstGeom prst="rect">
             <a:avLst/>
@@ -3973,8 +3973,8 @@
         </p:nvSpPr>
         <p:spPr>
           <a:xfrm>
-            <a:off x="914400" y="1722120"/>
-            <a:ext cx="2273198" cy="716280"/>
+            <a:off x="914400" y="1619794"/>
+            <a:ext cx="2273198" cy="613954"/>
           </a:xfrm>
           <a:prstGeom prst="rect">
             <a:avLst/>
@@ -3998,8 +3998,8 @@
         </p:nvSpPr>
         <p:spPr>
           <a:xfrm>
-            <a:off x="987552" y="1795272"/>
-            <a:ext cx="2126894" cy="588264"/>
+            <a:off x="987552" y="1692946"/>
+            <a:ext cx="2126894" cy="485938"/>
           </a:xfrm>
           <a:prstGeom prst="rect">
             <a:avLst/>
@@ -4036,8 +4036,8 @@
         </p:nvSpPr>
         <p:spPr>
           <a:xfrm>
-            <a:off x="3187598" y="1722120"/>
-            <a:ext cx="8059522" cy="716280"/>
+            <a:off x="3187598" y="1619794"/>
+            <a:ext cx="8059522" cy="613954"/>
           </a:xfrm>
           <a:prstGeom prst="rect">
             <a:avLst/>
@@ -4061,8 +4061,8 @@
         </p:nvSpPr>
         <p:spPr>
           <a:xfrm>
-            <a:off x="3260750" y="1795272"/>
-            <a:ext cx="7913218" cy="588264"/>
+            <a:off x="3260750" y="1692946"/>
+            <a:ext cx="7913218" cy="485938"/>
           </a:xfrm>
           <a:prstGeom prst="rect">
             <a:avLst/>
@@ -4099,8 +4099,8 @@
         </p:nvSpPr>
         <p:spPr>
           <a:xfrm>
-            <a:off x="914400" y="2438400"/>
-            <a:ext cx="2273198" cy="716280"/>
+            <a:off x="914400" y="2233749"/>
+            <a:ext cx="2273198" cy="613954"/>
           </a:xfrm>
           <a:prstGeom prst="rect">
             <a:avLst/>
@@ -4124,8 +4124,8 @@
         </p:nvSpPr>
         <p:spPr>
           <a:xfrm>
-            <a:off x="987552" y="2511552"/>
-            <a:ext cx="2126894" cy="588264"/>
+            <a:off x="987552" y="2306901"/>
+            <a:ext cx="2126894" cy="485938"/>
           </a:xfrm>
           <a:prstGeom prst="rect">
             <a:avLst/>
@@ -4162,8 +4162,8 @@
         </p:nvSpPr>
         <p:spPr>
           <a:xfrm>
-            <a:off x="3187598" y="2438400"/>
-            <a:ext cx="8059522" cy="716280"/>
+            <a:off x="3187598" y="2233749"/>
+            <a:ext cx="8059522" cy="613954"/>
           </a:xfrm>
           <a:prstGeom prst="rect">
             <a:avLst/>
@@ -4187,8 +4187,8 @@
         </p:nvSpPr>
         <p:spPr>
           <a:xfrm>
-            <a:off x="3260750" y="2511552"/>
-            <a:ext cx="7913218" cy="588264"/>
+            <a:off x="3260750" y="2306901"/>
+            <a:ext cx="7913218" cy="485938"/>
           </a:xfrm>
           <a:prstGeom prst="rect">
             <a:avLst/>
@@ -4225,8 +4225,8 @@
         </p:nvSpPr>
         <p:spPr>
           <a:xfrm>
-            <a:off x="914400" y="3154680"/>
-            <a:ext cx="2273198" cy="716280"/>
+            <a:off x="914400" y="2847703"/>
+            <a:ext cx="2273198" cy="613954"/>
           </a:xfrm>
           <a:prstGeom prst="rect">
             <a:avLst/>
@@ -4250,8 +4250,8 @@
         </p:nvSpPr>
         <p:spPr>
           <a:xfrm>
-            <a:off x="987552" y="3227832"/>
-            <a:ext cx="2126894" cy="588264"/>
+            <a:off x="987552" y="2920855"/>
+            <a:ext cx="2126894" cy="485938"/>
           </a:xfrm>
           <a:prstGeom prst="rect">
             <a:avLst/>
@@ -4288,8 +4288,8 @@
         </p:nvSpPr>
         <p:spPr>
           <a:xfrm>
-            <a:off x="3187598" y="3154680"/>
-            <a:ext cx="8059522" cy="716280"/>
+            <a:off x="3187598" y="2847703"/>
+            <a:ext cx="8059522" cy="613954"/>
           </a:xfrm>
           <a:prstGeom prst="rect">
             <a:avLst/>
@@ -4313,8 +4313,8 @@
         </p:nvSpPr>
         <p:spPr>
           <a:xfrm>
-            <a:off x="3260750" y="3227832"/>
-            <a:ext cx="7913218" cy="588264"/>
+            <a:off x="3260750" y="2920855"/>
+            <a:ext cx="7913218" cy="485938"/>
           </a:xfrm>
           <a:prstGeom prst="rect">
             <a:avLst/>
@@ -4351,8 +4351,8 @@
         </p:nvSpPr>
         <p:spPr>
           <a:xfrm>
-            <a:off x="914400" y="3870960"/>
-            <a:ext cx="2273198" cy="716280"/>
+            <a:off x="914400" y="3461657"/>
+            <a:ext cx="2273198" cy="613954"/>
           </a:xfrm>
           <a:prstGeom prst="rect">
             <a:avLst/>
@@ -4376,8 +4376,8 @@
         </p:nvSpPr>
         <p:spPr>
           <a:xfrm>
-            <a:off x="987552" y="3944112"/>
-            <a:ext cx="2126894" cy="588264"/>
+            <a:off x="987552" y="3534809"/>
+            <a:ext cx="2126894" cy="485938"/>
           </a:xfrm>
           <a:prstGeom prst="rect">
             <a:avLst/>
@@ -4414,8 +4414,8 @@
         </p:nvSpPr>
         <p:spPr>
           <a:xfrm>
-            <a:off x="3187598" y="3870960"/>
-            <a:ext cx="8059522" cy="716280"/>
+            <a:off x="3187598" y="3461657"/>
+            <a:ext cx="8059522" cy="613954"/>
           </a:xfrm>
           <a:prstGeom prst="rect">
             <a:avLst/>
@@ -4439,8 +4439,8 @@
         </p:nvSpPr>
         <p:spPr>
           <a:xfrm>
-            <a:off x="3260750" y="3944112"/>
-            <a:ext cx="7913218" cy="588264"/>
+            <a:off x="3260750" y="3534809"/>
+            <a:ext cx="7913218" cy="485938"/>
           </a:xfrm>
           <a:prstGeom prst="rect">
             <a:avLst/>
@@ -4463,7 +4463,7 @@
                   <a:srgbClr val="182230"/>
                 </a:solidFill>
               </a:rPr>
-              <a:t>MySQL 설정 시 members, shares, trade_logs 테이블</a:t>
+              <a:t>members, shares, trade_logs MySQL 필수 테이블</a:t>
             </a:r>
             <a:endParaRPr lang="en-US" sz="920" dirty="0"/>
           </a:p>
@@ -4477,8 +4477,8 @@
         </p:nvSpPr>
         <p:spPr>
           <a:xfrm>
-            <a:off x="914400" y="4587240"/>
-            <a:ext cx="2273198" cy="716280"/>
+            <a:off x="914400" y="4075611"/>
+            <a:ext cx="2273198" cy="613954"/>
           </a:xfrm>
           <a:prstGeom prst="rect">
             <a:avLst/>
@@ -4502,8 +4502,8 @@
         </p:nvSpPr>
         <p:spPr>
           <a:xfrm>
-            <a:off x="987552" y="4660392"/>
-            <a:ext cx="2126894" cy="588264"/>
+            <a:off x="987552" y="4148763"/>
+            <a:ext cx="2126894" cy="485938"/>
           </a:xfrm>
           <a:prstGeom prst="rect">
             <a:avLst/>
@@ -4526,6 +4526,132 @@
                   <a:srgbClr val="182230"/>
                 </a:solidFill>
               </a:rPr>
+              <a:t>주요 컬럼</a:t>
+            </a:r>
+            <a:endParaRPr lang="en-US" sz="920" dirty="0"/>
+          </a:p>
+        </p:txBody>
+      </p:sp>
+      <p:sp>
+        <p:nvSpPr>
+          <p:cNvPr id="28" name="Shape 26"/>
+          <p:cNvSpPr/>
+          <p:nvPr/>
+        </p:nvSpPr>
+        <p:spPr>
+          <a:xfrm>
+            <a:off x="3187598" y="4075611"/>
+            <a:ext cx="8059522" cy="613954"/>
+          </a:xfrm>
+          <a:prstGeom prst="rect">
+            <a:avLst/>
+          </a:prstGeom>
+          <a:solidFill>
+            <a:srgbClr val="FFFFFF"/>
+          </a:solidFill>
+          <a:ln w="7620">
+            <a:solidFill>
+              <a:srgbClr val="D7DEEA"/>
+            </a:solidFill>
+            <a:prstDash val="solid"/>
+          </a:ln>
+        </p:spPr>
+      </p:sp>
+      <p:sp>
+        <p:nvSpPr>
+          <p:cNvPr id="29" name="Text 27"/>
+          <p:cNvSpPr/>
+          <p:nvPr/>
+        </p:nvSpPr>
+        <p:spPr>
+          <a:xfrm>
+            <a:off x="3260750" y="4148763"/>
+            <a:ext cx="7913218" cy="485938"/>
+          </a:xfrm>
+          <a:prstGeom prst="rect">
+            <a:avLst/>
+          </a:prstGeom>
+          <a:noFill/>
+          <a:ln/>
+        </p:spPr>
+        <p:txBody>
+          <a:bodyPr wrap="square" lIns="0" tIns="0" rIns="0" bIns="0" rtlCol="0" anchor="ctr">
+            <a:normAutofit/>
+          </a:bodyPr>
+          <a:lstStyle/>
+          <a:p>
+            <a:pPr indent="0" marL="0">
+              <a:buNone/>
+            </a:pPr>
+            <a:r>
+              <a:rPr lang="en-US" sz="920" dirty="0">
+                <a:solidFill>
+                  <a:srgbClr val="182230"/>
+                </a:solidFill>
+              </a:rPr>
+              <a:t>login_id, pwd, purchase_price, trade_type, traded_at</a:t>
+            </a:r>
+            <a:endParaRPr lang="en-US" sz="920" dirty="0"/>
+          </a:p>
+        </p:txBody>
+      </p:sp>
+      <p:sp>
+        <p:nvSpPr>
+          <p:cNvPr id="30" name="Shape 28"/>
+          <p:cNvSpPr/>
+          <p:nvPr/>
+        </p:nvSpPr>
+        <p:spPr>
+          <a:xfrm>
+            <a:off x="914400" y="4689566"/>
+            <a:ext cx="2273198" cy="613954"/>
+          </a:xfrm>
+          <a:prstGeom prst="rect">
+            <a:avLst/>
+          </a:prstGeom>
+          <a:solidFill>
+            <a:srgbClr val="F6F9FD"/>
+          </a:solidFill>
+          <a:ln w="7620">
+            <a:solidFill>
+              <a:srgbClr val="D7DEEA"/>
+            </a:solidFill>
+            <a:prstDash val="solid"/>
+          </a:ln>
+        </p:spPr>
+      </p:sp>
+      <p:sp>
+        <p:nvSpPr>
+          <p:cNvPr id="31" name="Text 29"/>
+          <p:cNvSpPr/>
+          <p:nvPr/>
+        </p:nvSpPr>
+        <p:spPr>
+          <a:xfrm>
+            <a:off x="987552" y="4762718"/>
+            <a:ext cx="2126894" cy="485938"/>
+          </a:xfrm>
+          <a:prstGeom prst="rect">
+            <a:avLst/>
+          </a:prstGeom>
+          <a:noFill/>
+          <a:ln/>
+        </p:spPr>
+        <p:txBody>
+          <a:bodyPr wrap="square" lIns="0" tIns="0" rIns="0" bIns="0" rtlCol="0" anchor="ctr">
+            <a:normAutofit/>
+          </a:bodyPr>
+          <a:lstStyle/>
+          <a:p>
+            <a:pPr indent="0" marL="0">
+              <a:buNone/>
+            </a:pPr>
+            <a:r>
+              <a:rPr lang="en-US" sz="920" dirty="0">
+                <a:solidFill>
+                  <a:srgbClr val="182230"/>
+                </a:solidFill>
+              </a:rPr>
               <a:t>출력</a:t>
             </a:r>
             <a:endParaRPr lang="en-US" sz="920" dirty="0"/>
@@ -4534,20 +4660,20 @@
       </p:sp>
       <p:sp>
         <p:nvSpPr>
-          <p:cNvPr id="28" name="Shape 26"/>
-          <p:cNvSpPr/>
-          <p:nvPr/>
-        </p:nvSpPr>
-        <p:spPr>
-          <a:xfrm>
-            <a:off x="3187598" y="4587240"/>
-            <a:ext cx="8059522" cy="716280"/>
-          </a:xfrm>
-          <a:prstGeom prst="rect">
-            <a:avLst/>
-          </a:prstGeom>
-          <a:solidFill>
-            <a:srgbClr val="FFFFFF"/>
+          <p:cNvPr id="32" name="Shape 30"/>
+          <p:cNvSpPr/>
+          <p:nvPr/>
+        </p:nvSpPr>
+        <p:spPr>
+          <a:xfrm>
+            <a:off x="3187598" y="4689566"/>
+            <a:ext cx="8059522" cy="613954"/>
+          </a:xfrm>
+          <a:prstGeom prst="rect">
+            <a:avLst/>
+          </a:prstGeom>
+          <a:solidFill>
+            <a:srgbClr val="F6F9FD"/>
           </a:solidFill>
           <a:ln w="7620">
             <a:solidFill>
@@ -4559,14 +4685,14 @@
       </p:sp>
       <p:sp>
         <p:nvSpPr>
-          <p:cNvPr id="29" name="Text 27"/>
-          <p:cNvSpPr/>
-          <p:nvPr/>
-        </p:nvSpPr>
-        <p:spPr>
-          <a:xfrm>
-            <a:off x="3260750" y="4660392"/>
-            <a:ext cx="7913218" cy="588264"/>
+          <p:cNvPr id="33" name="Text 31"/>
+          <p:cNvSpPr/>
+          <p:nvPr/>
+        </p:nvSpPr>
+        <p:spPr>
+          <a:xfrm>
+            <a:off x="3260750" y="4762718"/>
+            <a:ext cx="7913218" cy="485938"/>
           </a:xfrm>
           <a:prstGeom prst="rect">
             <a:avLst/>
@@ -4766,7 +4892,7 @@
         <p:spPr>
           <a:xfrm>
             <a:off x="777240" y="914400"/>
-            <a:ext cx="2674620" cy="659674"/>
+            <a:ext cx="2674620" cy="577215"/>
           </a:xfrm>
           <a:prstGeom prst="rect">
             <a:avLst/>
@@ -4791,7 +4917,7 @@
         <p:spPr>
           <a:xfrm>
             <a:off x="850392" y="987552"/>
-            <a:ext cx="2528316" cy="531658"/>
+            <a:ext cx="2528316" cy="449199"/>
           </a:xfrm>
           <a:prstGeom prst="rect">
             <a:avLst/>
@@ -4829,7 +4955,7 @@
         <p:spPr>
           <a:xfrm>
             <a:off x="3451860" y="914400"/>
-            <a:ext cx="8023860" cy="659674"/>
+            <a:ext cx="8023860" cy="577215"/>
           </a:xfrm>
           <a:prstGeom prst="rect">
             <a:avLst/>
@@ -4854,7 +4980,7 @@
         <p:spPr>
           <a:xfrm>
             <a:off x="3525012" y="987552"/>
-            <a:ext cx="7877556" cy="531658"/>
+            <a:ext cx="7877556" cy="449199"/>
           </a:xfrm>
           <a:prstGeom prst="rect">
             <a:avLst/>
@@ -4891,8 +5017,8 @@
         </p:nvSpPr>
         <p:spPr>
           <a:xfrm>
-            <a:off x="777240" y="1574074"/>
-            <a:ext cx="2674620" cy="659674"/>
+            <a:off x="777240" y="1491615"/>
+            <a:ext cx="2674620" cy="577215"/>
           </a:xfrm>
           <a:prstGeom prst="rect">
             <a:avLst/>
@@ -4916,8 +5042,8 @@
         </p:nvSpPr>
         <p:spPr>
           <a:xfrm>
-            <a:off x="850392" y="1647226"/>
-            <a:ext cx="2528316" cy="531658"/>
+            <a:off x="850392" y="1564767"/>
+            <a:ext cx="2528316" cy="449199"/>
           </a:xfrm>
           <a:prstGeom prst="rect">
             <a:avLst/>
@@ -4954,8 +5080,8 @@
         </p:nvSpPr>
         <p:spPr>
           <a:xfrm>
-            <a:off x="3451860" y="1574074"/>
-            <a:ext cx="8023860" cy="659674"/>
+            <a:off x="3451860" y="1491615"/>
+            <a:ext cx="8023860" cy="577215"/>
           </a:xfrm>
           <a:prstGeom prst="rect">
             <a:avLst/>
@@ -4979,8 +5105,8 @@
         </p:nvSpPr>
         <p:spPr>
           <a:xfrm>
-            <a:off x="3525012" y="1647226"/>
-            <a:ext cx="7877556" cy="531658"/>
+            <a:off x="3525012" y="1564767"/>
+            <a:ext cx="7877556" cy="449199"/>
           </a:xfrm>
           <a:prstGeom prst="rect">
             <a:avLst/>
@@ -5017,8 +5143,8 @@
         </p:nvSpPr>
         <p:spPr>
           <a:xfrm>
-            <a:off x="777240" y="2233749"/>
-            <a:ext cx="2674620" cy="659674"/>
+            <a:off x="777240" y="2068830"/>
+            <a:ext cx="2674620" cy="577215"/>
           </a:xfrm>
           <a:prstGeom prst="rect">
             <a:avLst/>
@@ -5042,8 +5168,8 @@
         </p:nvSpPr>
         <p:spPr>
           <a:xfrm>
-            <a:off x="850392" y="2306901"/>
-            <a:ext cx="2528316" cy="531658"/>
+            <a:off x="850392" y="2141982"/>
+            <a:ext cx="2528316" cy="449199"/>
           </a:xfrm>
           <a:prstGeom prst="rect">
             <a:avLst/>
@@ -5080,8 +5206,8 @@
         </p:nvSpPr>
         <p:spPr>
           <a:xfrm>
-            <a:off x="3451860" y="2233749"/>
-            <a:ext cx="8023860" cy="659674"/>
+            <a:off x="3451860" y="2068830"/>
+            <a:ext cx="8023860" cy="577215"/>
           </a:xfrm>
           <a:prstGeom prst="rect">
             <a:avLst/>
@@ -5105,8 +5231,8 @@
         </p:nvSpPr>
         <p:spPr>
           <a:xfrm>
-            <a:off x="3525012" y="2306901"/>
-            <a:ext cx="7877556" cy="531658"/>
+            <a:off x="3525012" y="2141982"/>
+            <a:ext cx="7877556" cy="449199"/>
           </a:xfrm>
           <a:prstGeom prst="rect">
             <a:avLst/>
@@ -5143,8 +5269,8 @@
         </p:nvSpPr>
         <p:spPr>
           <a:xfrm>
-            <a:off x="777240" y="2893423"/>
-            <a:ext cx="2674620" cy="659674"/>
+            <a:off x="777240" y="2646045"/>
+            <a:ext cx="2674620" cy="577215"/>
           </a:xfrm>
           <a:prstGeom prst="rect">
             <a:avLst/>
@@ -5168,8 +5294,8 @@
         </p:nvSpPr>
         <p:spPr>
           <a:xfrm>
-            <a:off x="850392" y="2966575"/>
-            <a:ext cx="2528316" cy="531658"/>
+            <a:off x="850392" y="2719197"/>
+            <a:ext cx="2528316" cy="449199"/>
           </a:xfrm>
           <a:prstGeom prst="rect">
             <a:avLst/>
@@ -5192,7 +5318,7 @@
                   <a:srgbClr val="182230"/>
                 </a:solidFill>
               </a:rPr>
-              <a:t>실시간성</a:t>
+              <a:t>갱신 범위</a:t>
             </a:r>
             <a:endParaRPr lang="en-US" sz="920" dirty="0"/>
           </a:p>
@@ -5206,8 +5332,8 @@
         </p:nvSpPr>
         <p:spPr>
           <a:xfrm>
-            <a:off x="3451860" y="2893423"/>
-            <a:ext cx="8023860" cy="659674"/>
+            <a:off x="3451860" y="2646045"/>
+            <a:ext cx="8023860" cy="577215"/>
           </a:xfrm>
           <a:prstGeom prst="rect">
             <a:avLst/>
@@ -5231,8 +5357,8 @@
         </p:nvSpPr>
         <p:spPr>
           <a:xfrm>
-            <a:off x="3525012" y="2966575"/>
-            <a:ext cx="7877556" cy="531658"/>
+            <a:off x="3525012" y="2719197"/>
+            <a:ext cx="7877556" cy="449199"/>
           </a:xfrm>
           <a:prstGeom prst="rect">
             <a:avLst/>
@@ -5255,7 +5381,7 @@
                   <a:srgbClr val="182230"/>
                 </a:solidFill>
               </a:rPr>
-              <a:t>전체 종목 매초 조회 대신 상위 목록 중심 갱신 + 소켓 구독 구조 실험</a:t>
+              <a:t>KIS_MARKET_LIMIT 기본 200, 100~300개 제한 / KIS_POLL_LIMIT 기본 100</a:t>
             </a:r>
             <a:endParaRPr lang="en-US" sz="920" dirty="0"/>
           </a:p>
@@ -5269,8 +5395,8 @@
         </p:nvSpPr>
         <p:spPr>
           <a:xfrm>
-            <a:off x="777240" y="3553097"/>
-            <a:ext cx="2674620" cy="659674"/>
+            <a:off x="777240" y="3223260"/>
+            <a:ext cx="2674620" cy="577215"/>
           </a:xfrm>
           <a:prstGeom prst="rect">
             <a:avLst/>
@@ -5294,8 +5420,8 @@
         </p:nvSpPr>
         <p:spPr>
           <a:xfrm>
-            <a:off x="850392" y="3626249"/>
-            <a:ext cx="2528316" cy="531658"/>
+            <a:off x="850392" y="3296412"/>
+            <a:ext cx="2528316" cy="449199"/>
           </a:xfrm>
           <a:prstGeom prst="rect">
             <a:avLst/>
@@ -5318,7 +5444,7 @@
                   <a:srgbClr val="182230"/>
                 </a:solidFill>
               </a:rPr>
-              <a:t>소켓</a:t>
+              <a:t>실시간성</a:t>
             </a:r>
             <a:endParaRPr lang="en-US" sz="920" dirty="0"/>
           </a:p>
@@ -5332,8 +5458,8 @@
         </p:nvSpPr>
         <p:spPr>
           <a:xfrm>
-            <a:off x="3451860" y="3553097"/>
-            <a:ext cx="8023860" cy="659674"/>
+            <a:off x="3451860" y="3223260"/>
+            <a:ext cx="8023860" cy="577215"/>
           </a:xfrm>
           <a:prstGeom prst="rect">
             <a:avLst/>
@@ -5357,8 +5483,8 @@
         </p:nvSpPr>
         <p:spPr>
           <a:xfrm>
-            <a:off x="3525012" y="3626249"/>
-            <a:ext cx="7877556" cy="531658"/>
+            <a:off x="3525012" y="3296412"/>
+            <a:ext cx="7877556" cy="449199"/>
           </a:xfrm>
           <a:prstGeom prst="rect">
             <a:avLst/>
@@ -5381,7 +5507,7 @@
                   <a:srgbClr val="182230"/>
                 </a:solidFill>
               </a:rPr>
-              <a:t>모의 증권사 서버의 가격 Tick 구독 구조</a:t>
+              <a:t>전체 종목 매초 조회 대신 상위 목록 중심 갱신 + 소켓 구독 구조 실험</a:t>
             </a:r>
             <a:endParaRPr lang="en-US" sz="920" dirty="0"/>
           </a:p>
@@ -5395,8 +5521,8 @@
         </p:nvSpPr>
         <p:spPr>
           <a:xfrm>
-            <a:off x="777240" y="4212771"/>
-            <a:ext cx="2674620" cy="659674"/>
+            <a:off x="777240" y="3800475"/>
+            <a:ext cx="2674620" cy="577215"/>
           </a:xfrm>
           <a:prstGeom prst="rect">
             <a:avLst/>
@@ -5420,8 +5546,8 @@
         </p:nvSpPr>
         <p:spPr>
           <a:xfrm>
-            <a:off x="850392" y="4285923"/>
-            <a:ext cx="2528316" cy="531658"/>
+            <a:off x="850392" y="3873627"/>
+            <a:ext cx="2528316" cy="449199"/>
           </a:xfrm>
           <a:prstGeom prst="rect">
             <a:avLst/>
@@ -5444,7 +5570,7 @@
                   <a:srgbClr val="182230"/>
                 </a:solidFill>
               </a:rPr>
-              <a:t>사용자 데이터</a:t>
+              <a:t>소켓</a:t>
             </a:r>
             <a:endParaRPr lang="en-US" sz="920" dirty="0"/>
           </a:p>
@@ -5458,8 +5584,8 @@
         </p:nvSpPr>
         <p:spPr>
           <a:xfrm>
-            <a:off x="3451860" y="4212771"/>
-            <a:ext cx="8023860" cy="659674"/>
+            <a:off x="3451860" y="3800475"/>
+            <a:ext cx="8023860" cy="577215"/>
           </a:xfrm>
           <a:prstGeom prst="rect">
             <a:avLst/>
@@ -5483,8 +5609,8 @@
         </p:nvSpPr>
         <p:spPr>
           <a:xfrm>
-            <a:off x="3525012" y="4285923"/>
-            <a:ext cx="7877556" cy="531658"/>
+            <a:off x="3525012" y="3873627"/>
+            <a:ext cx="7877556" cy="449199"/>
           </a:xfrm>
           <a:prstGeom prst="rect">
             <a:avLst/>
@@ -5507,7 +5633,7 @@
                   <a:srgbClr val="182230"/>
                 </a:solidFill>
               </a:rPr>
-              <a:t>MySQL 설정 시 테이블 저장, 미설정 시 메모리 모드</a:t>
+              <a:t>모의 증권사 서버의 가격 Tick 구독 구조</a:t>
             </a:r>
             <a:endParaRPr lang="en-US" sz="920" dirty="0"/>
           </a:p>
@@ -5521,8 +5647,8 @@
         </p:nvSpPr>
         <p:spPr>
           <a:xfrm>
-            <a:off x="777240" y="4872446"/>
-            <a:ext cx="2674620" cy="659674"/>
+            <a:off x="777240" y="4377690"/>
+            <a:ext cx="2674620" cy="577215"/>
           </a:xfrm>
           <a:prstGeom prst="rect">
             <a:avLst/>
@@ -5546,8 +5672,8 @@
         </p:nvSpPr>
         <p:spPr>
           <a:xfrm>
-            <a:off x="850392" y="4945598"/>
-            <a:ext cx="2528316" cy="531658"/>
+            <a:off x="850392" y="4450842"/>
+            <a:ext cx="2528316" cy="449199"/>
           </a:xfrm>
           <a:prstGeom prst="rect">
             <a:avLst/>
@@ -5570,6 +5696,132 @@
                   <a:srgbClr val="182230"/>
                 </a:solidFill>
               </a:rPr>
+              <a:t>사용자 데이터</a:t>
+            </a:r>
+            <a:endParaRPr lang="en-US" sz="920" dirty="0"/>
+          </a:p>
+        </p:txBody>
+      </p:sp>
+      <p:sp>
+        <p:nvSpPr>
+          <p:cNvPr id="32" name="Shape 30"/>
+          <p:cNvSpPr/>
+          <p:nvPr/>
+        </p:nvSpPr>
+        <p:spPr>
+          <a:xfrm>
+            <a:off x="3451860" y="4377690"/>
+            <a:ext cx="8023860" cy="577215"/>
+          </a:xfrm>
+          <a:prstGeom prst="rect">
+            <a:avLst/>
+          </a:prstGeom>
+          <a:solidFill>
+            <a:srgbClr val="F6F9FD"/>
+          </a:solidFill>
+          <a:ln w="7620">
+            <a:solidFill>
+              <a:srgbClr val="D7DEEA"/>
+            </a:solidFill>
+            <a:prstDash val="solid"/>
+          </a:ln>
+        </p:spPr>
+      </p:sp>
+      <p:sp>
+        <p:nvSpPr>
+          <p:cNvPr id="33" name="Text 31"/>
+          <p:cNvSpPr/>
+          <p:nvPr/>
+        </p:nvSpPr>
+        <p:spPr>
+          <a:xfrm>
+            <a:off x="3525012" y="4450842"/>
+            <a:ext cx="7877556" cy="449199"/>
+          </a:xfrm>
+          <a:prstGeom prst="rect">
+            <a:avLst/>
+          </a:prstGeom>
+          <a:noFill/>
+          <a:ln/>
+        </p:spPr>
+        <p:txBody>
+          <a:bodyPr wrap="square" lIns="0" tIns="0" rIns="0" bIns="0" rtlCol="0" anchor="ctr">
+            <a:normAutofit/>
+          </a:bodyPr>
+          <a:lstStyle/>
+          <a:p>
+            <a:pPr indent="0" marL="0">
+              <a:buNone/>
+            </a:pPr>
+            <a:r>
+              <a:rPr lang="en-US" sz="920" dirty="0">
+                <a:solidFill>
+                  <a:srgbClr val="182230"/>
+                </a:solidFill>
+              </a:rPr>
+              <a:t>MySQL members, shares, trade_logs 테이블 저장</a:t>
+            </a:r>
+            <a:endParaRPr lang="en-US" sz="920" dirty="0"/>
+          </a:p>
+        </p:txBody>
+      </p:sp>
+      <p:sp>
+        <p:nvSpPr>
+          <p:cNvPr id="34" name="Shape 32"/>
+          <p:cNvSpPr/>
+          <p:nvPr/>
+        </p:nvSpPr>
+        <p:spPr>
+          <a:xfrm>
+            <a:off x="777240" y="4954905"/>
+            <a:ext cx="2674620" cy="577215"/>
+          </a:xfrm>
+          <a:prstGeom prst="rect">
+            <a:avLst/>
+          </a:prstGeom>
+          <a:solidFill>
+            <a:srgbClr val="FFFFFF"/>
+          </a:solidFill>
+          <a:ln w="7620">
+            <a:solidFill>
+              <a:srgbClr val="D7DEEA"/>
+            </a:solidFill>
+            <a:prstDash val="solid"/>
+          </a:ln>
+        </p:spPr>
+      </p:sp>
+      <p:sp>
+        <p:nvSpPr>
+          <p:cNvPr id="35" name="Text 33"/>
+          <p:cNvSpPr/>
+          <p:nvPr/>
+        </p:nvSpPr>
+        <p:spPr>
+          <a:xfrm>
+            <a:off x="850392" y="5028057"/>
+            <a:ext cx="2528316" cy="449199"/>
+          </a:xfrm>
+          <a:prstGeom prst="rect">
+            <a:avLst/>
+          </a:prstGeom>
+          <a:noFill/>
+          <a:ln/>
+        </p:spPr>
+        <p:txBody>
+          <a:bodyPr wrap="square" lIns="0" tIns="0" rIns="0" bIns="0" rtlCol="0" anchor="ctr">
+            <a:normAutofit/>
+          </a:bodyPr>
+          <a:lstStyle/>
+          <a:p>
+            <a:pPr indent="0" marL="0">
+              <a:buNone/>
+            </a:pPr>
+            <a:r>
+              <a:rPr lang="en-US" sz="920" dirty="0">
+                <a:solidFill>
+                  <a:srgbClr val="182230"/>
+                </a:solidFill>
+              </a:rPr>
               <a:t>가격 그래프</a:t>
             </a:r>
             <a:endParaRPr lang="en-US" sz="920" dirty="0"/>
@@ -5578,20 +5830,20 @@
       </p:sp>
       <p:sp>
         <p:nvSpPr>
-          <p:cNvPr id="32" name="Shape 30"/>
-          <p:cNvSpPr/>
-          <p:nvPr/>
-        </p:nvSpPr>
-        <p:spPr>
-          <a:xfrm>
-            <a:off x="3451860" y="4872446"/>
-            <a:ext cx="8023860" cy="659674"/>
-          </a:xfrm>
-          <a:prstGeom prst="rect">
-            <a:avLst/>
-          </a:prstGeom>
-          <a:solidFill>
-            <a:srgbClr val="F6F9FD"/>
+          <p:cNvPr id="36" name="Shape 34"/>
+          <p:cNvSpPr/>
+          <p:nvPr/>
+        </p:nvSpPr>
+        <p:spPr>
+          <a:xfrm>
+            <a:off x="3451860" y="4954905"/>
+            <a:ext cx="8023860" cy="577215"/>
+          </a:xfrm>
+          <a:prstGeom prst="rect">
+            <a:avLst/>
+          </a:prstGeom>
+          <a:solidFill>
+            <a:srgbClr val="FFFFFF"/>
           </a:solidFill>
           <a:ln w="7620">
             <a:solidFill>
@@ -5603,14 +5855,14 @@
       </p:sp>
       <p:sp>
         <p:nvSpPr>
-          <p:cNvPr id="33" name="Text 31"/>
-          <p:cNvSpPr/>
-          <p:nvPr/>
-        </p:nvSpPr>
-        <p:spPr>
-          <a:xfrm>
-            <a:off x="3525012" y="4945598"/>
-            <a:ext cx="7877556" cy="531658"/>
+          <p:cNvPr id="37" name="Text 35"/>
+          <p:cNvSpPr/>
+          <p:nvPr/>
+        </p:nvSpPr>
+        <p:spPr>
+          <a:xfrm>
+            <a:off x="3525012" y="5028057"/>
+            <a:ext cx="7877556" cy="449199"/>
           </a:xfrm>
           <a:prstGeom prst="rect">
             <a:avLst/>
@@ -10584,7 +10836,7 @@
                   <a:srgbClr val="182230"/>
                 </a:solidFill>
               </a:rPr>
-              <a:t>MySQL 설정 시 테이블 저장</a:t>
+              <a:t>MySQL 필수 테이블 저장</a:t>
             </a:r>
             <a:endParaRPr lang="en-US" sz="920" dirty="0"/>
           </a:p>
@@ -13695,7 +13947,7 @@
                   <a:srgbClr val="182230"/>
                 </a:solidFill>
               </a:rPr>
-              <a:t>업종·테마별 종목 분류 타입</a:t>
+              <a:t>업종·테마별 위험 설명 타입</a:t>
             </a:r>
             <a:endParaRPr lang="en-US" sz="920" dirty="0"/>
           </a:p>
@@ -14566,7 +14818,7 @@
                   <a:srgbClr val="182230"/>
                 </a:solidFill>
               </a:rPr>
-              <a:t>설계 이유: 100개 이상 타입 조건을 맞추면서도 회사 설명과 업종 분류를 의미 있는 구조로 분리했다.</a:t>
+              <a:t>설계 이유: 100개 이상 타입 조건을 맞추면서도 회사 설명과 업종 위험 설명이 실제 종목 상세에 쓰이도록 분리했다.</a:t>
             </a:r>
             <a:endParaRPr lang="en-US" sz="1400" dirty="0"/>
           </a:p>
@@ -16240,7 +16492,7 @@
                   <a:srgbClr val="182230"/>
                 </a:solidFill>
               </a:rPr>
-              <a:t>MySQL 설정 시 저장, 비밀번호 해시, 세션 기반 로그인</a:t>
+              <a:t>MySQL 필수 저장, 비밀번호 해시, 세션 기반 로그인</a:t>
             </a:r>
             <a:endParaRPr lang="en-US" sz="920" dirty="0"/>
           </a:p>

</xml_diff>

<commit_message>
Simplify project flow without login
</commit_message>
<xml_diff>
--- a/deliverables/Java_모의주식투자_발표자료_최종정합본.pptx
+++ b/deliverables/Java_모의주식투자_발표자료_최종정합본.pptx
@@ -4085,7 +4085,7 @@
                   <a:srgbClr val="182230"/>
                 </a:solidFill>
               </a:rPr>
-              <a:t>로그인 정보, 종목 선택, 즐겨찾기, 매수/매도 수량</a:t>
+              <a:t>종목 선택, 즐겨찾기, 매수/매도 수량</a:t>
             </a:r>
             <a:endParaRPr lang="en-US" sz="920" dirty="0"/>
           </a:p>
@@ -4463,7 +4463,7 @@
                   <a:srgbClr val="182230"/>
                 </a:solidFill>
               </a:rPr>
-              <a:t>members, shares, trade_logs MySQL 필수 테이블</a:t>
+              <a:t>members(uid, name, balance) / shares / trade_logs</a:t>
             </a:r>
             <a:endParaRPr lang="en-US" sz="920" dirty="0"/>
           </a:p>
@@ -4589,7 +4589,7 @@
                   <a:srgbClr val="182230"/>
                 </a:solidFill>
               </a:rPr>
-              <a:t>login_id, pwd, purchase_price, trade_type, traded_at</a:t>
+              <a:t>purchase_price, trade_type, traded_at</a:t>
             </a:r>
             <a:endParaRPr lang="en-US" sz="920" dirty="0"/>
           </a:p>
@@ -6836,20 +6836,6 @@
                 <a:ea typeface="Malgun Gothic" pitchFamily="34" charset="-122"/>
                 <a:cs typeface="Malgun Gothic" pitchFamily="34" charset="-120"/>
               </a:rPr>
-              <a:t>SecureRandom, MessageDigest: 비밀번호 Salt 생성과 해시 검증</a:t>
-            </a:r>
-            <a:endParaRPr lang="en-US" sz="1400" dirty="0"/>
-          </a:p>
-          <a:p>
-            <a:r>
-              <a:rPr lang="en-US" sz="1400" dirty="0">
-                <a:solidFill>
-                  <a:srgbClr val="182230"/>
-                </a:solidFill>
-                <a:latin typeface="Malgun Gothic" pitchFamily="34" charset="0"/>
-                <a:ea typeface="Malgun Gothic" pitchFamily="34" charset="-122"/>
-                <a:cs typeface="Malgun Gothic" pitchFamily="34" charset="-120"/>
-              </a:rPr>
               <a:t>LocalDateTime, DateTimeFormatter: 거래 시간과 시세 갱신 시각 표시</a:t>
             </a:r>
             <a:endParaRPr lang="en-US" sz="1400" dirty="0"/>
@@ -7119,7 +7105,7 @@
                 <a:ea typeface="Consolas" pitchFamily="34" charset="-122"/>
                 <a:cs typeface="Consolas" pitchFamily="34" charset="-120"/>
               </a:rPr>
-              <a:t>String sessionId = sessionCookie(exchange);</a:t>
+              <a:t>if ("GET".equals(method) &amp;&amp; "/api/state".equals(path)) {</a:t>
             </a:r>
             <a:endParaRPr lang="en-US" sz="690" dirty="0"/>
           </a:p>
@@ -7136,7 +7122,7 @@
                 <a:ea typeface="Consolas" pitchFamily="34" charset="-122"/>
                 <a:cs typeface="Consolas" pitchFamily="34" charset="-120"/>
               </a:rPr>
-              <a:t>if ("GET".equals(method) &amp;&amp; "/api/state".equals(path)) {</a:t>
+              <a:t>    send(exchange, 200, "application/json", project.stateJson());</a:t>
             </a:r>
             <a:endParaRPr lang="en-US" sz="690" dirty="0"/>
           </a:p>
@@ -7153,7 +7139,7 @@
                 <a:ea typeface="Consolas" pitchFamily="34" charset="-122"/>
                 <a:cs typeface="Consolas" pitchFamily="34" charset="-120"/>
               </a:rPr>
-              <a:t>    send(exchange, 200, "application/json", project.stateJson(sessionId));</a:t>
+              <a:t>}</a:t>
             </a:r>
             <a:endParaRPr lang="en-US" sz="690" dirty="0"/>
           </a:p>
@@ -7170,7 +7156,7 @@
                 <a:ea typeface="Consolas" pitchFamily="34" charset="-122"/>
                 <a:cs typeface="Consolas" pitchFamily="34" charset="-120"/>
               </a:rPr>
-              <a:t>}</a:t>
+              <a:t>String json = switch (path) {</a:t>
             </a:r>
             <a:endParaRPr lang="en-US" sz="690" dirty="0"/>
           </a:p>
@@ -7187,7 +7173,7 @@
                 <a:ea typeface="Consolas" pitchFamily="34" charset="-122"/>
                 <a:cs typeface="Consolas" pitchFamily="34" charset="-120"/>
               </a:rPr>
-              <a:t>String json = switch (path) {</a:t>
+              <a:t>    case "/api/stock/buy" -&gt; project.buyStock(body);</a:t>
             </a:r>
             <a:endParaRPr lang="en-US" sz="690" dirty="0"/>
           </a:p>
@@ -7204,24 +7190,7 @@
                 <a:ea typeface="Consolas" pitchFamily="34" charset="-122"/>
                 <a:cs typeface="Consolas" pitchFamily="34" charset="-120"/>
               </a:rPr>
-              <a:t>    case "/api/stock/buy" -&gt; project.buyStock(body, sessionId);</a:t>
-            </a:r>
-            <a:endParaRPr lang="en-US" sz="690" dirty="0"/>
-          </a:p>
-          <a:p>
-            <a:pPr indent="0" marL="0">
-              <a:buNone/>
-            </a:pPr>
-            <a:r>
-              <a:rPr lang="en-US" sz="690" dirty="0">
-                <a:solidFill>
-                  <a:srgbClr val="E5E7EB"/>
-                </a:solidFill>
-                <a:latin typeface="Consolas" pitchFamily="34" charset="0"/>
-                <a:ea typeface="Consolas" pitchFamily="34" charset="-122"/>
-                <a:cs typeface="Consolas" pitchFamily="34" charset="-120"/>
-              </a:rPr>
-              <a:t>    case "/api/stock/sell" -&gt; project.sellStock(body, sessionId);</a:t>
+              <a:t>    case "/api/stock/sell" -&gt; project.sellStock(body);</a:t>
             </a:r>
             <a:endParaRPr lang="en-US" sz="690" dirty="0"/>
           </a:p>
@@ -7571,7 +7540,7 @@
                 <a:ea typeface="Consolas" pitchFamily="34" charset="-122"/>
                 <a:cs typeface="Consolas" pitchFamily="34" charset="-120"/>
               </a:rPr>
-              <a:t>Member member = member(sessionId);</a:t>
+              <a:t>Member member = defaultMember();</a:t>
             </a:r>
             <a:endParaRPr lang="en-US" sz="690" dirty="0"/>
           </a:p>
@@ -8160,7 +8129,7 @@
                   <a:srgbClr val="1F5FBF"/>
                 </a:solidFill>
               </a:rPr>
-              <a:t>보안/세션 보완</a:t>
+              <a:t>로그인 제거</a:t>
             </a:r>
             <a:endParaRPr lang="en-US" sz="1200" dirty="0"/>
           </a:p>
@@ -8198,7 +8167,7 @@
                   <a:srgbClr val="182230"/>
                 </a:solidFill>
               </a:rPr>
-              <a:t>비밀번호는 Salt+SHA-256 해시로 저장하고, 로그인 상태는 HttpOnly 쿠키 세션으로 관리</a:t>
+              <a:t>과제용 프로젝트라 회원 인증보다 종목 조회와 매매 흐름에 집중하도록 단일 투자자 구조로 단순화</a:t>
             </a:r>
             <a:endParaRPr lang="en-US" sz="1070" dirty="0"/>
           </a:p>
@@ -8665,7 +8634,7 @@
                   <a:srgbClr val="1F5FBF"/>
                 </a:solidFill>
               </a:rPr>
-              <a:t>배포 보완</a:t>
+              <a:t>문서 정합성</a:t>
             </a:r>
             <a:endParaRPr lang="en-US" sz="1200" dirty="0"/>
           </a:p>
@@ -8703,7 +8672,7 @@
                   <a:srgbClr val="182230"/>
                 </a:solidFill>
               </a:rPr>
-              <a:t>HTTPS, 세션 만료 시간, CSRF 방어는 실제 배포 단계에서 추가 필요</a:t>
+              <a:t>PPT, 보고서, README가 실제 코드 구조와 같은 용어를 쓰도록 정리</a:t>
             </a:r>
             <a:endParaRPr lang="en-US" sz="1070" dirty="0"/>
           </a:p>
@@ -9180,7 +9149,7 @@
                   <a:srgbClr val="182230"/>
                 </a:solidFill>
               </a:rPr>
-              <a:t>로그인과 상단 요약</a:t>
+              <a:t>상단 요약</a:t>
             </a:r>
             <a:endParaRPr lang="en-US" sz="920" dirty="0"/>
           </a:p>
@@ -9243,7 +9212,7 @@
                   <a:srgbClr val="182230"/>
                 </a:solidFill>
               </a:rPr>
-              <a:t>Java 웹앱으로 실행되는 점 설명</a:t>
+              <a:t>로그인 없이 바로 모의투자 화면이 열리는 점 설명</a:t>
             </a:r>
             <a:endParaRPr lang="en-US" sz="920" dirty="0"/>
           </a:p>
@@ -10021,7 +9990,7 @@
                 <a:ea typeface="Malgun Gothic" pitchFamily="34" charset="-122"/>
                 <a:cs typeface="Malgun Gothic" pitchFamily="34" charset="-120"/>
               </a:rPr>
-              <a:t>제안발표 전 vs 최종 구현</a:t>
+              <a:t>발표 흐름</a:t>
             </a:r>
             <a:endParaRPr lang="en-US" sz="1600" dirty="0"/>
           </a:p>
@@ -10143,7 +10112,7 @@
                   <a:srgbClr val="FFFFFF"/>
                 </a:solidFill>
               </a:rPr>
-              <a:t>구분</a:t>
+              <a:t>순서</a:t>
             </a:r>
             <a:endParaRPr lang="en-US" sz="1000" dirty="0"/>
           </a:p>
@@ -10206,7 +10175,7 @@
                   <a:srgbClr val="FFFFFF"/>
                 </a:solidFill>
               </a:rPr>
-              <a:t>제안발표 단계</a:t>
+              <a:t>발표 내용</a:t>
             </a:r>
             <a:endParaRPr lang="en-US" sz="1000" dirty="0"/>
           </a:p>
@@ -10269,7 +10238,7 @@
                   <a:srgbClr val="FFFFFF"/>
                 </a:solidFill>
               </a:rPr>
-              <a:t>최종 구현</a:t>
+              <a:t>핵심 질문</a:t>
             </a:r>
             <a:endParaRPr lang="en-US" sz="1000" dirty="0"/>
           </a:p>
@@ -10332,7 +10301,7 @@
                   <a:srgbClr val="182230"/>
                 </a:solidFill>
               </a:rPr>
-              <a:t>주제</a:t>
+              <a:t>1</a:t>
             </a:r>
             <a:endParaRPr lang="en-US" sz="920" dirty="0"/>
           </a:p>
@@ -10395,7 +10364,7 @@
                   <a:srgbClr val="182230"/>
                 </a:solidFill>
               </a:rPr>
-              <a:t>기본 Java 기능 구현</a:t>
+              <a:t>왜 만들었는가</a:t>
             </a:r>
             <a:endParaRPr lang="en-US" sz="920" dirty="0"/>
           </a:p>
@@ -10458,7 +10427,7 @@
                   <a:srgbClr val="182230"/>
                 </a:solidFill>
               </a:rPr>
-              <a:t>실제 증권 API 기반 모의주식투자</a:t>
+              <a:t>과제용 모의투자에서 무엇을 보여줄 것인가</a:t>
             </a:r>
             <a:endParaRPr lang="en-US" sz="920" dirty="0"/>
           </a:p>
@@ -10521,7 +10490,7 @@
                   <a:srgbClr val="182230"/>
                 </a:solidFill>
               </a:rPr>
-              <a:t>데이터</a:t>
+              <a:t>2</a:t>
             </a:r>
             <a:endParaRPr lang="en-US" sz="920" dirty="0"/>
           </a:p>
@@ -10584,7 +10553,7 @@
                   <a:srgbClr val="182230"/>
                 </a:solidFill>
               </a:rPr>
-              <a:t>초기 샘플/내부 데이터</a:t>
+              <a:t>사용자는 어떻게 쓰는가</a:t>
             </a:r>
             <a:endParaRPr lang="en-US" sz="920" dirty="0"/>
           </a:p>
@@ -10647,7 +10616,7 @@
                   <a:srgbClr val="182230"/>
                 </a:solidFill>
               </a:rPr>
-              <a:t>KIS 현재가, 등락률, 누적 거래량</a:t>
+              <a:t>로그인 없이 종목을 보고 바로 매매할 수 있는가</a:t>
             </a:r>
             <a:endParaRPr lang="en-US" sz="920" dirty="0"/>
           </a:p>
@@ -10710,7 +10679,7 @@
                   <a:srgbClr val="182230"/>
                 </a:solidFill>
               </a:rPr>
-              <a:t>저장</a:t>
+              <a:t>3</a:t>
             </a:r>
             <a:endParaRPr lang="en-US" sz="920" dirty="0"/>
           </a:p>
@@ -10773,7 +10742,7 @@
                   <a:srgbClr val="182230"/>
                 </a:solidFill>
               </a:rPr>
-              <a:t>메모리 중심 구상</a:t>
+              <a:t>데이터는 어떻게 흐르는가</a:t>
             </a:r>
             <a:endParaRPr lang="en-US" sz="920" dirty="0"/>
           </a:p>
@@ -10836,7 +10805,7 @@
                   <a:srgbClr val="182230"/>
                 </a:solidFill>
               </a:rPr>
-              <a:t>MySQL 필수 테이블 저장</a:t>
+              <a:t>KIS 시세, MySQL 저장, 포트폴리오 계산이 어떻게 연결되는가</a:t>
             </a:r>
             <a:endParaRPr lang="en-US" sz="920" dirty="0"/>
           </a:p>
@@ -10899,7 +10868,7 @@
                   <a:srgbClr val="182230"/>
                 </a:solidFill>
               </a:rPr>
-              <a:t>화면</a:t>
+              <a:t>4</a:t>
             </a:r>
             <a:endParaRPr lang="en-US" sz="920" dirty="0"/>
           </a:p>
@@ -10962,7 +10931,7 @@
                   <a:srgbClr val="182230"/>
                 </a:solidFill>
               </a:rPr>
-              <a:t>기본 목록과 입력 화면</a:t>
+              <a:t>Java 코드는 어떻게 나뉘는가</a:t>
             </a:r>
             <a:endParaRPr lang="en-US" sz="920" dirty="0"/>
           </a:p>
@@ -11025,7 +10994,7 @@
                   <a:srgbClr val="182230"/>
                 </a:solidFill>
               </a:rPr>
-              <a:t>종목 상세, 그래프, 포트폴리오</a:t>
+              <a:t>서버, 서비스, DB, 외부 API, 화면 역할이 분리되는가</a:t>
             </a:r>
             <a:endParaRPr lang="en-US" sz="920" dirty="0"/>
           </a:p>
@@ -11088,7 +11057,7 @@
                   <a:srgbClr val="182230"/>
                 </a:solidFill>
               </a:rPr>
-              <a:t>흐름</a:t>
+              <a:t>5</a:t>
             </a:r>
             <a:endParaRPr lang="en-US" sz="920" dirty="0"/>
           </a:p>
@@ -11151,7 +11120,7 @@
                   <a:srgbClr val="182230"/>
                 </a:solidFill>
               </a:rPr>
-              <a:t>드롭다운 선택 후 주문</a:t>
+              <a:t>어떤 시행착오가 있었는가</a:t>
             </a:r>
             <a:endParaRPr lang="en-US" sz="920" dirty="0"/>
           </a:p>
@@ -11214,7 +11183,7 @@
                   <a:srgbClr val="182230"/>
                 </a:solidFill>
               </a:rPr>
-              <a:t>종목 클릭 → 상세 확인 → 매수/매도</a:t>
+              <a:t>실제 개발 중 바꾼 판단은 무엇인가</a:t>
             </a:r>
             <a:endParaRPr lang="en-US" sz="920" dirty="0"/>
           </a:p>
@@ -11250,7 +11219,7 @@
                   <a:srgbClr val="1F5FBF"/>
                 </a:solidFill>
               </a:rPr>
-              <a:t>변경 이유: 모의주식투자라는 주제라면 임의 가격보다 실제 시세와 거래량을 쓰는 편이 목적이 더 분명하다고 판단했다.</a:t>
+              <a:t>발표는 기능 나열보다 사용 흐름과 데이터 흐름을 먼저 설명한 뒤, 그 흐름을 Java 코드가 어떻게 처리하는지 보여주는 순서로 진행한다.</a:t>
             </a:r>
             <a:endParaRPr lang="en-US" sz="1320" dirty="0"/>
           </a:p>
@@ -12954,7 +12923,7 @@
         <p:spPr>
           <a:xfrm>
             <a:off x="640080" y="868680"/>
-            <a:ext cx="3730752" cy="568960"/>
+            <a:ext cx="3730752" cy="640080"/>
           </a:xfrm>
           <a:prstGeom prst="rect">
             <a:avLst/>
@@ -12979,7 +12948,7 @@
         <p:spPr>
           <a:xfrm>
             <a:off x="713232" y="941832"/>
-            <a:ext cx="3584448" cy="440944"/>
+            <a:ext cx="3584448" cy="512064"/>
           </a:xfrm>
           <a:prstGeom prst="rect">
             <a:avLst/>
@@ -13017,7 +12986,7 @@
         <p:spPr>
           <a:xfrm>
             <a:off x="4370832" y="868680"/>
-            <a:ext cx="7242048" cy="568960"/>
+            <a:ext cx="7242048" cy="640080"/>
           </a:xfrm>
           <a:prstGeom prst="rect">
             <a:avLst/>
@@ -13042,7 +13011,7 @@
         <p:spPr>
           <a:xfrm>
             <a:off x="4443984" y="941832"/>
-            <a:ext cx="7095744" cy="440944"/>
+            <a:ext cx="7095744" cy="512064"/>
           </a:xfrm>
           <a:prstGeom prst="rect">
             <a:avLst/>
@@ -13079,8 +13048,8 @@
         </p:nvSpPr>
         <p:spPr>
           <a:xfrm>
-            <a:off x="640080" y="1437640"/>
-            <a:ext cx="3730752" cy="568960"/>
+            <a:off x="640080" y="1508760"/>
+            <a:ext cx="3730752" cy="640080"/>
           </a:xfrm>
           <a:prstGeom prst="rect">
             <a:avLst/>
@@ -13104,8 +13073,8 @@
         </p:nvSpPr>
         <p:spPr>
           <a:xfrm>
-            <a:off x="713232" y="1510792"/>
-            <a:ext cx="3584448" cy="440944"/>
+            <a:off x="713232" y="1581912"/>
+            <a:ext cx="3584448" cy="512064"/>
           </a:xfrm>
           <a:prstGeom prst="rect">
             <a:avLst/>
@@ -13142,8 +13111,8 @@
         </p:nvSpPr>
         <p:spPr>
           <a:xfrm>
-            <a:off x="4370832" y="1437640"/>
-            <a:ext cx="7242048" cy="568960"/>
+            <a:off x="4370832" y="1508760"/>
+            <a:ext cx="7242048" cy="640080"/>
           </a:xfrm>
           <a:prstGeom prst="rect">
             <a:avLst/>
@@ -13167,8 +13136,8 @@
         </p:nvSpPr>
         <p:spPr>
           <a:xfrm>
-            <a:off x="4443984" y="1510792"/>
-            <a:ext cx="7095744" cy="440944"/>
+            <a:off x="4443984" y="1581912"/>
+            <a:ext cx="7095744" cy="512064"/>
           </a:xfrm>
           <a:prstGeom prst="rect">
             <a:avLst/>
@@ -13205,8 +13174,8 @@
         </p:nvSpPr>
         <p:spPr>
           <a:xfrm>
-            <a:off x="640080" y="2006600"/>
-            <a:ext cx="3730752" cy="568960"/>
+            <a:off x="640080" y="2148840"/>
+            <a:ext cx="3730752" cy="640080"/>
           </a:xfrm>
           <a:prstGeom prst="rect">
             <a:avLst/>
@@ -13230,8 +13199,8 @@
         </p:nvSpPr>
         <p:spPr>
           <a:xfrm>
-            <a:off x="713232" y="2079752"/>
-            <a:ext cx="3584448" cy="440944"/>
+            <a:off x="713232" y="2221992"/>
+            <a:ext cx="3584448" cy="512064"/>
           </a:xfrm>
           <a:prstGeom prst="rect">
             <a:avLst/>
@@ -13268,8 +13237,8 @@
         </p:nvSpPr>
         <p:spPr>
           <a:xfrm>
-            <a:off x="4370832" y="2006600"/>
-            <a:ext cx="7242048" cy="568960"/>
+            <a:off x="4370832" y="2148840"/>
+            <a:ext cx="7242048" cy="640080"/>
           </a:xfrm>
           <a:prstGeom prst="rect">
             <a:avLst/>
@@ -13293,8 +13262,8 @@
         </p:nvSpPr>
         <p:spPr>
           <a:xfrm>
-            <a:off x="4443984" y="2079752"/>
-            <a:ext cx="7095744" cy="440944"/>
+            <a:off x="4443984" y="2221992"/>
+            <a:ext cx="7095744" cy="512064"/>
           </a:xfrm>
           <a:prstGeom prst="rect">
             <a:avLst/>
@@ -13331,8 +13300,8 @@
         </p:nvSpPr>
         <p:spPr>
           <a:xfrm>
-            <a:off x="640080" y="2575560"/>
-            <a:ext cx="3730752" cy="568960"/>
+            <a:off x="640080" y="2788920"/>
+            <a:ext cx="3730752" cy="640080"/>
           </a:xfrm>
           <a:prstGeom prst="rect">
             <a:avLst/>
@@ -13356,8 +13325,8 @@
         </p:nvSpPr>
         <p:spPr>
           <a:xfrm>
-            <a:off x="713232" y="2648712"/>
-            <a:ext cx="3584448" cy="440944"/>
+            <a:off x="713232" y="2862072"/>
+            <a:ext cx="3584448" cy="512064"/>
           </a:xfrm>
           <a:prstGeom prst="rect">
             <a:avLst/>
@@ -13394,8 +13363,8 @@
         </p:nvSpPr>
         <p:spPr>
           <a:xfrm>
-            <a:off x="4370832" y="2575560"/>
-            <a:ext cx="7242048" cy="568960"/>
+            <a:off x="4370832" y="2788920"/>
+            <a:ext cx="7242048" cy="640080"/>
           </a:xfrm>
           <a:prstGeom prst="rect">
             <a:avLst/>
@@ -13419,8 +13388,8 @@
         </p:nvSpPr>
         <p:spPr>
           <a:xfrm>
-            <a:off x="4443984" y="2648712"/>
-            <a:ext cx="7095744" cy="440944"/>
+            <a:off x="4443984" y="2862072"/>
+            <a:ext cx="7095744" cy="512064"/>
           </a:xfrm>
           <a:prstGeom prst="rect">
             <a:avLst/>
@@ -13443,7 +13412,7 @@
                   <a:srgbClr val="182230"/>
                 </a:solidFill>
               </a:rPr>
-              <a:t>회원, 매매, 포트폴리오, 시세 상태 핵심 로직</a:t>
+              <a:t>과제용 투자자, 매매, 포트폴리오, 시세 상태 핵심 로직</a:t>
             </a:r>
             <a:endParaRPr lang="en-US" sz="920" dirty="0"/>
           </a:p>
@@ -13457,8 +13426,8 @@
         </p:nvSpPr>
         <p:spPr>
           <a:xfrm>
-            <a:off x="640080" y="3144520"/>
-            <a:ext cx="3730752" cy="568960"/>
+            <a:off x="640080" y="3429000"/>
+            <a:ext cx="3730752" cy="640080"/>
           </a:xfrm>
           <a:prstGeom prst="rect">
             <a:avLst/>
@@ -13482,8 +13451,8 @@
         </p:nvSpPr>
         <p:spPr>
           <a:xfrm>
-            <a:off x="713232" y="3217672"/>
-            <a:ext cx="3584448" cy="440944"/>
+            <a:off x="713232" y="3502152"/>
+            <a:ext cx="3584448" cy="512064"/>
           </a:xfrm>
           <a:prstGeom prst="rect">
             <a:avLst/>
@@ -13520,8 +13489,8 @@
         </p:nvSpPr>
         <p:spPr>
           <a:xfrm>
-            <a:off x="4370832" y="3144520"/>
-            <a:ext cx="7242048" cy="568960"/>
+            <a:off x="4370832" y="3429000"/>
+            <a:ext cx="7242048" cy="640080"/>
           </a:xfrm>
           <a:prstGeom prst="rect">
             <a:avLst/>
@@ -13545,8 +13514,8 @@
         </p:nvSpPr>
         <p:spPr>
           <a:xfrm>
-            <a:off x="4443984" y="3217672"/>
-            <a:ext cx="7095744" cy="440944"/>
+            <a:off x="4443984" y="3502152"/>
+            <a:ext cx="7095744" cy="512064"/>
           </a:xfrm>
           <a:prstGeom prst="rect">
             <a:avLst/>
@@ -13583,8 +13552,8 @@
         </p:nvSpPr>
         <p:spPr>
           <a:xfrm>
-            <a:off x="640080" y="3713480"/>
-            <a:ext cx="3730752" cy="568960"/>
+            <a:off x="640080" y="4069080"/>
+            <a:ext cx="3730752" cy="640080"/>
           </a:xfrm>
           <a:prstGeom prst="rect">
             <a:avLst/>
@@ -13608,8 +13577,8 @@
         </p:nvSpPr>
         <p:spPr>
           <a:xfrm>
-            <a:off x="713232" y="3786632"/>
-            <a:ext cx="3584448" cy="440944"/>
+            <a:off x="713232" y="4142232"/>
+            <a:ext cx="3584448" cy="512064"/>
           </a:xfrm>
           <a:prstGeom prst="rect">
             <a:avLst/>
@@ -13646,8 +13615,8 @@
         </p:nvSpPr>
         <p:spPr>
           <a:xfrm>
-            <a:off x="4370832" y="3713480"/>
-            <a:ext cx="7242048" cy="568960"/>
+            <a:off x="4370832" y="4069080"/>
+            <a:ext cx="7242048" cy="640080"/>
           </a:xfrm>
           <a:prstGeom prst="rect">
             <a:avLst/>
@@ -13671,8 +13640,8 @@
         </p:nvSpPr>
         <p:spPr>
           <a:xfrm>
-            <a:off x="4443984" y="3786632"/>
-            <a:ext cx="7095744" cy="440944"/>
+            <a:off x="4443984" y="4142232"/>
+            <a:ext cx="7095744" cy="512064"/>
           </a:xfrm>
           <a:prstGeom prst="rect">
             <a:avLst/>
@@ -13709,8 +13678,8 @@
         </p:nvSpPr>
         <p:spPr>
           <a:xfrm>
-            <a:off x="640080" y="4282440"/>
-            <a:ext cx="3730752" cy="568960"/>
+            <a:off x="640080" y="4709160"/>
+            <a:ext cx="3730752" cy="640080"/>
           </a:xfrm>
           <a:prstGeom prst="rect">
             <a:avLst/>
@@ -13734,8 +13703,8 @@
         </p:nvSpPr>
         <p:spPr>
           <a:xfrm>
-            <a:off x="713232" y="4355592"/>
-            <a:ext cx="3584448" cy="440944"/>
+            <a:off x="713232" y="4782312"/>
+            <a:ext cx="3584448" cy="512064"/>
           </a:xfrm>
           <a:prstGeom prst="rect">
             <a:avLst/>
@@ -13758,7 +13727,7 @@
                   <a:srgbClr val="182230"/>
                 </a:solidFill>
               </a:rPr>
-              <a:t>PasswordHasher.java</a:t>
+              <a:t>StockCategoryProfiles.java</a:t>
             </a:r>
             <a:endParaRPr lang="en-US" sz="920" dirty="0"/>
           </a:p>
@@ -13772,8 +13741,8 @@
         </p:nvSpPr>
         <p:spPr>
           <a:xfrm>
-            <a:off x="4370832" y="4282440"/>
-            <a:ext cx="7242048" cy="568960"/>
+            <a:off x="4370832" y="4709160"/>
+            <a:ext cx="7242048" cy="640080"/>
           </a:xfrm>
           <a:prstGeom prst="rect">
             <a:avLst/>
@@ -13797,8 +13766,8 @@
         </p:nvSpPr>
         <p:spPr>
           <a:xfrm>
-            <a:off x="4443984" y="4355592"/>
-            <a:ext cx="7095744" cy="440944"/>
+            <a:off x="4443984" y="4782312"/>
+            <a:ext cx="7095744" cy="512064"/>
           </a:xfrm>
           <a:prstGeom prst="rect">
             <a:avLst/>
@@ -13821,7 +13790,7 @@
                   <a:srgbClr val="182230"/>
                 </a:solidFill>
               </a:rPr>
-              <a:t>Salt 기반 SHA-256 비밀번호 해시와 검증</a:t>
+              <a:t>업종·테마별 위험 설명 타입</a:t>
             </a:r>
             <a:endParaRPr lang="en-US" sz="920" dirty="0"/>
           </a:p>
@@ -13835,8 +13804,8 @@
         </p:nvSpPr>
         <p:spPr>
           <a:xfrm>
-            <a:off x="640080" y="4851400"/>
-            <a:ext cx="3730752" cy="568960"/>
+            <a:off x="640080" y="5349240"/>
+            <a:ext cx="3730752" cy="640080"/>
           </a:xfrm>
           <a:prstGeom prst="rect">
             <a:avLst/>
@@ -13860,8 +13829,8 @@
         </p:nvSpPr>
         <p:spPr>
           <a:xfrm>
-            <a:off x="713232" y="4924552"/>
-            <a:ext cx="3584448" cy="440944"/>
+            <a:off x="713232" y="5422392"/>
+            <a:ext cx="3584448" cy="512064"/>
           </a:xfrm>
           <a:prstGeom prst="rect">
             <a:avLst/>
@@ -13884,7 +13853,7 @@
                   <a:srgbClr val="182230"/>
                 </a:solidFill>
               </a:rPr>
-              <a:t>StockCategoryProfiles.java</a:t>
+              <a:t>WebPages.java</a:t>
             </a:r>
             <a:endParaRPr lang="en-US" sz="920" dirty="0"/>
           </a:p>
@@ -13898,8 +13867,8 @@
         </p:nvSpPr>
         <p:spPr>
           <a:xfrm>
-            <a:off x="4370832" y="4851400"/>
-            <a:ext cx="7242048" cy="568960"/>
+            <a:off x="4370832" y="5349240"/>
+            <a:ext cx="7242048" cy="640080"/>
           </a:xfrm>
           <a:prstGeom prst="rect">
             <a:avLst/>
@@ -13923,134 +13892,8 @@
         </p:nvSpPr>
         <p:spPr>
           <a:xfrm>
-            <a:off x="4443984" y="4924552"/>
-            <a:ext cx="7095744" cy="440944"/>
-          </a:xfrm>
-          <a:prstGeom prst="rect">
-            <a:avLst/>
-          </a:prstGeom>
-          <a:noFill/>
-          <a:ln/>
-        </p:spPr>
-        <p:txBody>
-          <a:bodyPr wrap="square" lIns="0" tIns="0" rIns="0" bIns="0" rtlCol="0" anchor="ctr">
-            <a:normAutofit/>
-          </a:bodyPr>
-          <a:lstStyle/>
-          <a:p>
-            <a:pPr indent="0" marL="0">
-              <a:buNone/>
-            </a:pPr>
-            <a:r>
-              <a:rPr lang="en-US" sz="920" dirty="0">
-                <a:solidFill>
-                  <a:srgbClr val="182230"/>
-                </a:solidFill>
-              </a:rPr>
-              <a:t>업종·테마별 위험 설명 타입</a:t>
-            </a:r>
-            <a:endParaRPr lang="en-US" sz="920" dirty="0"/>
-          </a:p>
-        </p:txBody>
-      </p:sp>
-      <p:sp>
-        <p:nvSpPr>
-          <p:cNvPr id="38" name="Shape 36"/>
-          <p:cNvSpPr/>
-          <p:nvPr/>
-        </p:nvSpPr>
-        <p:spPr>
-          <a:xfrm>
-            <a:off x="640080" y="5420360"/>
-            <a:ext cx="3730752" cy="568960"/>
-          </a:xfrm>
-          <a:prstGeom prst="rect">
-            <a:avLst/>
-          </a:prstGeom>
-          <a:solidFill>
-            <a:srgbClr val="F6F9FD"/>
-          </a:solidFill>
-          <a:ln w="7620">
-            <a:solidFill>
-              <a:srgbClr val="D7DEEA"/>
-            </a:solidFill>
-            <a:prstDash val="solid"/>
-          </a:ln>
-        </p:spPr>
-      </p:sp>
-      <p:sp>
-        <p:nvSpPr>
-          <p:cNvPr id="39" name="Text 37"/>
-          <p:cNvSpPr/>
-          <p:nvPr/>
-        </p:nvSpPr>
-        <p:spPr>
-          <a:xfrm>
-            <a:off x="713232" y="5493512"/>
-            <a:ext cx="3584448" cy="440944"/>
-          </a:xfrm>
-          <a:prstGeom prst="rect">
-            <a:avLst/>
-          </a:prstGeom>
-          <a:noFill/>
-          <a:ln/>
-        </p:spPr>
-        <p:txBody>
-          <a:bodyPr wrap="square" lIns="0" tIns="0" rIns="0" bIns="0" rtlCol="0" anchor="ctr">
-            <a:normAutofit/>
-          </a:bodyPr>
-          <a:lstStyle/>
-          <a:p>
-            <a:pPr indent="0" marL="0">
-              <a:buNone/>
-            </a:pPr>
-            <a:r>
-              <a:rPr lang="en-US" sz="920" dirty="0">
-                <a:solidFill>
-                  <a:srgbClr val="182230"/>
-                </a:solidFill>
-              </a:rPr>
-              <a:t>WebPages.java</a:t>
-            </a:r>
-            <a:endParaRPr lang="en-US" sz="920" dirty="0"/>
-          </a:p>
-        </p:txBody>
-      </p:sp>
-      <p:sp>
-        <p:nvSpPr>
-          <p:cNvPr id="40" name="Shape 38"/>
-          <p:cNvSpPr/>
-          <p:nvPr/>
-        </p:nvSpPr>
-        <p:spPr>
-          <a:xfrm>
-            <a:off x="4370832" y="5420360"/>
-            <a:ext cx="7242048" cy="568960"/>
-          </a:xfrm>
-          <a:prstGeom prst="rect">
-            <a:avLst/>
-          </a:prstGeom>
-          <a:solidFill>
-            <a:srgbClr val="F6F9FD"/>
-          </a:solidFill>
-          <a:ln w="7620">
-            <a:solidFill>
-              <a:srgbClr val="D7DEEA"/>
-            </a:solidFill>
-            <a:prstDash val="solid"/>
-          </a:ln>
-        </p:spPr>
-      </p:sp>
-      <p:sp>
-        <p:nvSpPr>
-          <p:cNvPr id="41" name="Text 39"/>
-          <p:cNvSpPr/>
-          <p:nvPr/>
-        </p:nvSpPr>
-        <p:spPr>
-          <a:xfrm>
-            <a:off x="4443984" y="5493512"/>
-            <a:ext cx="7095744" cy="440944"/>
+            <a:off x="4443984" y="5422392"/>
+            <a:ext cx="7095744" cy="512064"/>
           </a:xfrm>
           <a:prstGeom prst="rect">
             <a:avLst/>
@@ -16303,7 +16146,7 @@
                   <a:srgbClr val="182230"/>
                 </a:solidFill>
               </a:rPr>
-              <a:t>저장소/보안</a:t>
+              <a:t>저장소</a:t>
             </a:r>
             <a:endParaRPr lang="en-US" sz="920" dirty="0"/>
           </a:p>
@@ -16366,7 +16209,7 @@
                   <a:srgbClr val="182230"/>
                 </a:solidFill>
               </a:rPr>
-              <a:t>MySqlDatabase, PasswordHasher</a:t>
+              <a:t>MySqlDatabase, DatabaseSnapshot</a:t>
             </a:r>
             <a:endParaRPr lang="en-US" sz="920" dirty="0"/>
           </a:p>
@@ -16429,7 +16272,7 @@
                   <a:srgbClr val="182230"/>
                 </a:solidFill>
               </a:rPr>
-              <a:t>JDBC, DriverManager, SecureRandom, MessageDigest</a:t>
+              <a:t>JDBC, DriverManager, PreparedStatement</a:t>
             </a:r>
             <a:endParaRPr lang="en-US" sz="920" dirty="0"/>
           </a:p>
@@ -16492,7 +16335,7 @@
                   <a:srgbClr val="182230"/>
                 </a:solidFill>
               </a:rPr>
-              <a:t>MySQL 필수 저장, 비밀번호 해시, 세션 기반 로그인</a:t>
+              <a:t>MySQL 필수 저장, 스키마 생성, 데이터 로드</a:t>
             </a:r>
             <a:endParaRPr lang="en-US" sz="920" dirty="0"/>
           </a:p>
@@ -18337,7 +18180,7 @@
                   <a:srgbClr val="182230"/>
                 </a:solidFill>
               </a:rPr>
-              <a:t>1. 접속/로그인</a:t>
+              <a:t>1. 웹사이트 접속</a:t>
             </a:r>
             <a:endParaRPr lang="en-US" sz="1080" dirty="0"/>
           </a:p>

</xml_diff>

<commit_message>
Allow local storage fallback for localhost demo
</commit_message>
<xml_diff>
--- a/deliverables/Java_모의주식투자_발표자료_최종정합본.pptx
+++ b/deliverables/Java_모의주식투자_발표자료_최종정합본.pptx
@@ -5759,7 +5759,7 @@
                   <a:srgbClr val="182230"/>
                 </a:solidFill>
               </a:rPr>
-              <a:t>MySQL members, shares, trade_logs 테이블 저장</a:t>
+              <a:t>MySQL 우선 저장, 실패 시 data/local-database.tsv 저장</a:t>
             </a:r>
             <a:endParaRPr lang="en-US" sz="920" dirty="0"/>
           </a:p>
@@ -6552,7 +6552,7 @@
                   <a:srgbClr val="182230"/>
                 </a:solidFill>
               </a:rPr>
-              <a:t>서버를 껐다 켜면 기록이 사라지는 문제를 MySQL 저장 구조로 바꿔 거래 기록을 유지</a:t>
+              <a:t>서버를 껐다 켜면 기록이 사라지는 문제를 MySQL/로컬 파일 저장 구조로 바꿔 거래 기록을 유지</a:t>
             </a:r>
             <a:endParaRPr lang="en-US" sz="1070" dirty="0"/>
           </a:p>
@@ -6836,6 +6836,20 @@
                 <a:ea typeface="Malgun Gothic" pitchFamily="34" charset="-122"/>
                 <a:cs typeface="Malgun Gothic" pitchFamily="34" charset="-120"/>
               </a:rPr>
+              <a:t>Files, Path: MySQL 연결 실패 시 로컬 파일 저장소 사용</a:t>
+            </a:r>
+            <a:endParaRPr lang="en-US" sz="1400" dirty="0"/>
+          </a:p>
+          <a:p>
+            <a:r>
+              <a:rPr lang="en-US" sz="1400" dirty="0">
+                <a:solidFill>
+                  <a:srgbClr val="182230"/>
+                </a:solidFill>
+                <a:latin typeface="Malgun Gothic" pitchFamily="34" charset="0"/>
+                <a:ea typeface="Malgun Gothic" pitchFamily="34" charset="-122"/>
+                <a:cs typeface="Malgun Gothic" pitchFamily="34" charset="-120"/>
+              </a:rPr>
               <a:t>LocalDateTime, DateTimeFormatter: 거래 시간과 시세 갱신 시각 표시</a:t>
             </a:r>
             <a:endParaRPr lang="en-US" sz="1400" dirty="0"/>
@@ -10805,7 +10819,7 @@
                   <a:srgbClr val="182230"/>
                 </a:solidFill>
               </a:rPr>
-              <a:t>KIS 시세, MySQL 저장, 포트폴리오 계산이 어떻게 연결되는가</a:t>
+              <a:t>KIS 시세, 저장소, 포트폴리오 계산이 어떻게 연결되는가</a:t>
             </a:r>
             <a:endParaRPr lang="en-US" sz="920" dirty="0"/>
           </a:p>
@@ -11722,7 +11736,7 @@
                 <a:ea typeface="Malgun Gothic" pitchFamily="34" charset="-122"/>
                 <a:cs typeface="Malgun Gothic" pitchFamily="34" charset="-120"/>
               </a:rPr>
-              <a:t>외부 API, MySQL 저장 구조, 소켓 통신, 컬렉션을 하나의 Java 프로젝트 안에서 연결</a:t>
+              <a:t>외부 API, 저장소 구조, 소켓 통신, 컬렉션을 하나의 Java 프로젝트 안에서 연결</a:t>
             </a:r>
             <a:endParaRPr lang="en-US" sz="1500" dirty="0"/>
           </a:p>
@@ -13538,7 +13552,7 @@
                   <a:srgbClr val="182230"/>
                 </a:solidFill>
               </a:rPr>
-              <a:t>MySQL 연결, 테이블 생성, 저장/로드</a:t>
+              <a:t>MySQL 우선 연결, 로컬 파일 저장 전환</a:t>
             </a:r>
             <a:endParaRPr lang="en-US" sz="920" dirty="0"/>
           </a:p>
@@ -16209,7 +16223,7 @@
                   <a:srgbClr val="182230"/>
                 </a:solidFill>
               </a:rPr>
-              <a:t>MySqlDatabase, DatabaseSnapshot</a:t>
+              <a:t>MySqlDatabase, LocalFileDatabase</a:t>
             </a:r>
             <a:endParaRPr lang="en-US" sz="920" dirty="0"/>
           </a:p>
@@ -16272,7 +16286,7 @@
                   <a:srgbClr val="182230"/>
                 </a:solidFill>
               </a:rPr>
-              <a:t>JDBC, DriverManager, PreparedStatement</a:t>
+              <a:t>JDBC, DriverManager, Files, Path</a:t>
             </a:r>
             <a:endParaRPr lang="en-US" sz="920" dirty="0"/>
           </a:p>
@@ -16335,7 +16349,7 @@
                   <a:srgbClr val="182230"/>
                 </a:solidFill>
               </a:rPr>
-              <a:t>MySQL 필수 저장, 스키마 생성, 데이터 로드</a:t>
+              <a:t>MySQL 우선 저장, 실패 시 로컬 파일 저장</a:t>
             </a:r>
             <a:endParaRPr lang="en-US" sz="920" dirty="0"/>
           </a:p>

</xml_diff>

<commit_message>
Remove assignment investor wording
</commit_message>
<xml_diff>
--- a/deliverables/Java_모의주식투자_발표자료_최종정합본.pptx
+++ b/deliverables/Java_모의주식투자_발표자료_최종정합본.pptx
@@ -8181,7 +8181,7 @@
                   <a:srgbClr val="182230"/>
                 </a:solidFill>
               </a:rPr>
-              <a:t>과제용 프로젝트라 회원 인증보다 종목 조회와 매매 흐름에 집중하도록 단일 투자자 구조로 단순화</a:t>
+              <a:t>과제용 프로젝트라 회원 인증보다 종목 조회와 매매 흐름에 집중하도록 단일 모의 계좌 구조로 단순화</a:t>
             </a:r>
             <a:endParaRPr lang="en-US" sz="1070" dirty="0"/>
           </a:p>
@@ -13426,7 +13426,7 @@
                   <a:srgbClr val="182230"/>
                 </a:solidFill>
               </a:rPr>
-              <a:t>과제용 투자자, 매매, 포트폴리오, 시세 상태 핵심 로직</a:t>
+              <a:t>모의 계좌, 매매, 포트폴리오, 시세 상태 핵심 로직</a:t>
             </a:r>
             <a:endParaRPr lang="en-US" sz="920" dirty="0"/>
           </a:p>

</xml_diff>

<commit_message>
Reorganize packages and refresh trading UI
</commit_message>
<xml_diff>
--- a/deliverables/Java_모의주식투자_발표자료_최종정합본.pptx
+++ b/deliverables/Java_모의주식투자_발표자료_최종정합본.pptx
@@ -7277,7 +7277,7 @@
                 <a:ea typeface="Malgun Gothic" pitchFamily="34" charset="-122"/>
                 <a:cs typeface="Malgun Gothic" pitchFamily="34" charset="-120"/>
               </a:rPr>
-              <a:t>KIS 현재가 조회 - KisIntegration.java</a:t>
+              <a:t>KIS 현재가 조회 - external/KisQuotePoller.java</a:t>
             </a:r>
             <a:endParaRPr lang="en-US" sz="1050" dirty="0"/>
           </a:p>
@@ -7712,7 +7712,7 @@
                 <a:ea typeface="Malgun Gothic" pitchFamily="34" charset="-122"/>
                 <a:cs typeface="Malgun Gothic" pitchFamily="34" charset="-120"/>
               </a:rPr>
-              <a:t>MySQL 저장 - DatabaseIntegration.java</a:t>
+              <a:t>MySQL 저장 - repository/MySqlDatabase.java</a:t>
             </a:r>
             <a:endParaRPr lang="en-US" sz="1050" dirty="0"/>
           </a:p>
@@ -8446,7 +8446,7 @@
                   <a:srgbClr val="1F5FBF"/>
                 </a:solidFill>
               </a:rPr>
-              <a:t>구조 개선 계획</a:t>
+              <a:t>구조 개선</a:t>
             </a:r>
             <a:endParaRPr lang="en-US" sz="1200" dirty="0"/>
           </a:p>
@@ -8484,7 +8484,7 @@
                   <a:srgbClr val="182230"/>
                 </a:solidFill>
               </a:rPr>
-              <a:t>현재는 루트 파일 중심, 이후 controller/service/repository/model 패키지 분리 예정</a:t>
+              <a:t>src/main/java 아래 app/controller/service/domain/repository/external/view/util 패키지로 분리</a:t>
             </a:r>
             <a:endParaRPr lang="en-US" sz="1070" dirty="0"/>
           </a:p>
@@ -13111,7 +13111,7 @@
                   <a:srgbClr val="182230"/>
                 </a:solidFill>
               </a:rPr>
-              <a:t>MiniProjectApp.java</a:t>
+              <a:t>app/MiniProjectApp.java</a:t>
             </a:r>
             <a:endParaRPr lang="en-US" sz="920" dirty="0"/>
           </a:p>
@@ -13489,7 +13489,7 @@
                   <a:srgbClr val="182230"/>
                 </a:solidFill>
               </a:rPr>
-              <a:t>DatabaseIntegration.java</a:t>
+              <a:t>repository/MySqlDatabase.java</a:t>
             </a:r>
             <a:endParaRPr lang="en-US" sz="920" dirty="0"/>
           </a:p>
@@ -13615,7 +13615,7 @@
                   <a:srgbClr val="182230"/>
                 </a:solidFill>
               </a:rPr>
-              <a:t>KisIntegration.java</a:t>
+              <a:t>external/KisQuotePoller.java</a:t>
             </a:r>
             <a:endParaRPr lang="en-US" sz="920" dirty="0"/>
           </a:p>
@@ -13867,7 +13867,7 @@
                   <a:srgbClr val="182230"/>
                 </a:solidFill>
               </a:rPr>
-              <a:t>WebPages.java</a:t>
+              <a:t>view/MiniDashboardPage.java</a:t>
             </a:r>
             <a:endParaRPr lang="en-US" sz="920" dirty="0"/>
           </a:p>
@@ -14193,7 +14193,7 @@
                   <a:srgbClr val="182230"/>
                 </a:solidFill>
               </a:rPr>
-              <a:t>MiniProjectApp → MiniHandler → MiniProject</a:t>
+              <a:t>app.MiniProjectApp → controller.MiniHandler → service.MiniProject</a:t>
             </a:r>
             <a:endParaRPr lang="en-US" sz="1070" dirty="0"/>
           </a:p>
@@ -14423,7 +14423,7 @@
                   <a:srgbClr val="182230"/>
                 </a:solidFill>
               </a:rPr>
-              <a:t>KisQuoteClient, BrokerIntegration</a:t>
+              <a:t>KisQuoteClient, MockBrokerServer</a:t>
             </a:r>
             <a:endParaRPr lang="en-US" sz="1070" dirty="0"/>
           </a:p>
@@ -15215,7 +15215,7 @@
                   <a:srgbClr val="182230"/>
                 </a:solidFill>
               </a:rPr>
-              <a:t>MiniProjectApp, MiniHandler</a:t>
+              <a:t>app.MiniProjectApp, controller.MiniHandler</a:t>
             </a:r>
             <a:endParaRPr lang="en-US" sz="920" dirty="0"/>
           </a:p>
@@ -16475,7 +16475,7 @@
                   <a:srgbClr val="182230"/>
                 </a:solidFill>
               </a:rPr>
-              <a:t>WebPages, Json, CompanyProfile, StockCategoryProfile</a:t>
+              <a:t>view.MiniDashboardPage, util.Json, CompanyProfile, StockCategoryProfile</a:t>
             </a:r>
             <a:endParaRPr lang="en-US" sz="920" dirty="0"/>
           </a:p>
@@ -16637,7 +16637,7 @@
                   <a:srgbClr val="1F5FBF"/>
                 </a:solidFill>
               </a:rPr>
-              <a:t>정리해서 말하면 서버, 서비스, 외부 API, DB, 보안, 화면 역할을 나눴고, 제출용 컴파일을 쉽게 하기 위해 현재는 루트 파일 중심으로 유지했다.</a:t>
+              <a:t>정리해서 말하면 서버, 서비스, 외부 API, DB, 화면 역할을 실제 패키지로 나눴고, 제출용 컴파일도 src/main/java 전체를 기준으로 검증한다.</a:t>
             </a:r>
             <a:endParaRPr lang="en-US" sz="1250" dirty="0"/>
           </a:p>

</xml_diff>

<commit_message>
Refine final presentation consistency
</commit_message>
<xml_diff>
--- a/deliverables/Java_모의주식투자_발표자료_최종정합본.pptx
+++ b/deliverables/Java_모의주식투자_발표자료_최종정합본.pptx
@@ -6989,7 +6989,7 @@
                 <a:ea typeface="Malgun Gothic" pitchFamily="34" charset="-122"/>
                 <a:cs typeface="Malgun Gothic" pitchFamily="34" charset="-120"/>
               </a:rPr>
-              <a:t>주요 코드 일부</a:t>
+              <a:t>주요 코드 흐름</a:t>
             </a:r>
             <a:endParaRPr lang="en-US" sz="1600" dirty="0"/>
           </a:p>
@@ -7056,14 +7056,560 @@
       </p:sp>
       <p:sp>
         <p:nvSpPr>
-          <p:cNvPr id="6" name="Text 4"/>
-          <p:cNvSpPr/>
-          <p:nvPr/>
-        </p:nvSpPr>
-        <p:spPr>
-          <a:xfrm>
-            <a:off x="594360" y="868680"/>
-            <a:ext cx="5303520" cy="219456"/>
+          <p:cNvPr id="6" name="Shape 4"/>
+          <p:cNvSpPr/>
+          <p:nvPr/>
+        </p:nvSpPr>
+        <p:spPr>
+          <a:xfrm>
+            <a:off x="594360" y="914400"/>
+            <a:ext cx="2514600" cy="1325880"/>
+          </a:xfrm>
+          <a:prstGeom prst="roundRect">
+            <a:avLst>
+              <a:gd name="adj" fmla="val 4138"/>
+            </a:avLst>
+          </a:prstGeom>
+          <a:solidFill>
+            <a:srgbClr val="FFFFFF"/>
+          </a:solidFill>
+          <a:ln w="12700">
+            <a:solidFill>
+              <a:srgbClr val="D7DEEA"/>
+            </a:solidFill>
+            <a:prstDash val="solid"/>
+          </a:ln>
+        </p:spPr>
+      </p:sp>
+      <p:sp>
+        <p:nvSpPr>
+          <p:cNvPr id="7" name="Text 5"/>
+          <p:cNvSpPr/>
+          <p:nvPr/>
+        </p:nvSpPr>
+        <p:spPr>
+          <a:xfrm>
+            <a:off x="758952" y="1060704"/>
+            <a:ext cx="2185416" cy="237744"/>
+          </a:xfrm>
+          <a:prstGeom prst="rect">
+            <a:avLst/>
+          </a:prstGeom>
+          <a:noFill/>
+          <a:ln/>
+        </p:spPr>
+        <p:txBody>
+          <a:bodyPr wrap="square" lIns="0" tIns="0" rIns="0" bIns="0" rtlCol="0" anchor="ctr"/>
+          <a:lstStyle/>
+          <a:p>
+            <a:pPr indent="0" marL="0">
+              <a:buNone/>
+            </a:pPr>
+            <a:r>
+              <a:rPr lang="en-US" sz="1200" b="1" dirty="0">
+                <a:solidFill>
+                  <a:srgbClr val="1F5FBF"/>
+                </a:solidFill>
+              </a:rPr>
+              <a:t>1. 브라우저 요청</a:t>
+            </a:r>
+            <a:endParaRPr lang="en-US" sz="1200" dirty="0"/>
+          </a:p>
+        </p:txBody>
+      </p:sp>
+      <p:sp>
+        <p:nvSpPr>
+          <p:cNvPr id="8" name="Text 6"/>
+          <p:cNvSpPr/>
+          <p:nvPr/>
+        </p:nvSpPr>
+        <p:spPr>
+          <a:xfrm>
+            <a:off x="758952" y="1389888"/>
+            <a:ext cx="2185416" cy="731520"/>
+          </a:xfrm>
+          <a:prstGeom prst="rect">
+            <a:avLst/>
+          </a:prstGeom>
+          <a:noFill/>
+          <a:ln/>
+        </p:spPr>
+        <p:txBody>
+          <a:bodyPr wrap="square" lIns="381" tIns="381" rIns="381" bIns="381" rtlCol="0" anchor="ctr">
+            <a:normAutofit/>
+          </a:bodyPr>
+          <a:lstStyle/>
+          <a:p>
+            <a:pPr indent="0" marL="0">
+              <a:buNone/>
+            </a:pPr>
+            <a:r>
+              <a:rPr lang="en-US" sz="1070" dirty="0">
+                <a:solidFill>
+                  <a:srgbClr val="182230"/>
+                </a:solidFill>
+              </a:rPr>
+              <a:t>GET /api/state</a:t>
+            </a:r>
+            <a:endParaRPr lang="en-US" sz="1070" dirty="0"/>
+          </a:p>
+          <a:p>
+            <a:pPr indent="0" marL="0">
+              <a:buNone/>
+            </a:pPr>
+            <a:r>
+              <a:rPr lang="en-US" sz="1070" dirty="0">
+                <a:solidFill>
+                  <a:srgbClr val="182230"/>
+                </a:solidFill>
+              </a:rPr>
+              <a:t>POST /api/stock/buy</a:t>
+            </a:r>
+            <a:endParaRPr lang="en-US" sz="1070" dirty="0"/>
+          </a:p>
+          <a:p>
+            <a:pPr indent="0" marL="0">
+              <a:buNone/>
+            </a:pPr>
+            <a:r>
+              <a:rPr lang="en-US" sz="1070" dirty="0">
+                <a:solidFill>
+                  <a:srgbClr val="182230"/>
+                </a:solidFill>
+              </a:rPr>
+              <a:t>POST /api/stock/sell</a:t>
+            </a:r>
+            <a:endParaRPr lang="en-US" sz="1070" dirty="0"/>
+          </a:p>
+        </p:txBody>
+      </p:sp>
+      <p:sp>
+        <p:nvSpPr>
+          <p:cNvPr id="9" name="Shape 7"/>
+          <p:cNvSpPr/>
+          <p:nvPr/>
+        </p:nvSpPr>
+        <p:spPr>
+          <a:xfrm>
+            <a:off x="3108960" y="1572768"/>
+            <a:ext cx="265176" cy="0"/>
+          </a:xfrm>
+          <a:prstGeom prst="line">
+            <a:avLst/>
+          </a:prstGeom>
+          <a:noFill/>
+          <a:ln w="25400">
+            <a:solidFill>
+              <a:srgbClr val="1F5FBF"/>
+            </a:solidFill>
+            <a:prstDash val="solid"/>
+            <a:tailEnd type="triangle"/>
+          </a:ln>
+        </p:spPr>
+      </p:sp>
+      <p:sp>
+        <p:nvSpPr>
+          <p:cNvPr id="10" name="Shape 8"/>
+          <p:cNvSpPr/>
+          <p:nvPr/>
+        </p:nvSpPr>
+        <p:spPr>
+          <a:xfrm>
+            <a:off x="3410712" y="914400"/>
+            <a:ext cx="2514600" cy="1325880"/>
+          </a:xfrm>
+          <a:prstGeom prst="roundRect">
+            <a:avLst>
+              <a:gd name="adj" fmla="val 4138"/>
+            </a:avLst>
+          </a:prstGeom>
+          <a:solidFill>
+            <a:srgbClr val="FFFFFF"/>
+          </a:solidFill>
+          <a:ln w="12700">
+            <a:solidFill>
+              <a:srgbClr val="D7DEEA"/>
+            </a:solidFill>
+            <a:prstDash val="solid"/>
+          </a:ln>
+        </p:spPr>
+      </p:sp>
+      <p:sp>
+        <p:nvSpPr>
+          <p:cNvPr id="11" name="Text 9"/>
+          <p:cNvSpPr/>
+          <p:nvPr/>
+        </p:nvSpPr>
+        <p:spPr>
+          <a:xfrm>
+            <a:off x="3575304" y="1060704"/>
+            <a:ext cx="2185416" cy="237744"/>
+          </a:xfrm>
+          <a:prstGeom prst="rect">
+            <a:avLst/>
+          </a:prstGeom>
+          <a:noFill/>
+          <a:ln/>
+        </p:spPr>
+        <p:txBody>
+          <a:bodyPr wrap="square" lIns="0" tIns="0" rIns="0" bIns="0" rtlCol="0" anchor="ctr"/>
+          <a:lstStyle/>
+          <a:p>
+            <a:pPr indent="0" marL="0">
+              <a:buNone/>
+            </a:pPr>
+            <a:r>
+              <a:rPr lang="en-US" sz="1200" b="1" dirty="0">
+                <a:solidFill>
+                  <a:srgbClr val="1F5FBF"/>
+                </a:solidFill>
+              </a:rPr>
+              <a:t>2. MiniHandler</a:t>
+            </a:r>
+            <a:endParaRPr lang="en-US" sz="1200" dirty="0"/>
+          </a:p>
+        </p:txBody>
+      </p:sp>
+      <p:sp>
+        <p:nvSpPr>
+          <p:cNvPr id="12" name="Text 10"/>
+          <p:cNvSpPr/>
+          <p:nvPr/>
+        </p:nvSpPr>
+        <p:spPr>
+          <a:xfrm>
+            <a:off x="3575304" y="1389888"/>
+            <a:ext cx="2185416" cy="731520"/>
+          </a:xfrm>
+          <a:prstGeom prst="rect">
+            <a:avLst/>
+          </a:prstGeom>
+          <a:noFill/>
+          <a:ln/>
+        </p:spPr>
+        <p:txBody>
+          <a:bodyPr wrap="square" lIns="381" tIns="381" rIns="381" bIns="381" rtlCol="0" anchor="ctr">
+            <a:normAutofit/>
+          </a:bodyPr>
+          <a:lstStyle/>
+          <a:p>
+            <a:pPr indent="0" marL="0">
+              <a:buNone/>
+            </a:pPr>
+            <a:r>
+              <a:rPr lang="en-US" sz="1070" dirty="0">
+                <a:solidFill>
+                  <a:srgbClr val="182230"/>
+                </a:solidFill>
+              </a:rPr>
+              <a:t>URL을 확인하고</a:t>
+            </a:r>
+            <a:endParaRPr lang="en-US" sz="1070" dirty="0"/>
+          </a:p>
+          <a:p>
+            <a:pPr indent="0" marL="0">
+              <a:buNone/>
+            </a:pPr>
+            <a:r>
+              <a:rPr lang="en-US" sz="1070" dirty="0">
+                <a:solidFill>
+                  <a:srgbClr val="182230"/>
+                </a:solidFill>
+              </a:rPr>
+              <a:t>MiniProject 메서드 호출</a:t>
+            </a:r>
+            <a:endParaRPr lang="en-US" sz="1070" dirty="0"/>
+          </a:p>
+        </p:txBody>
+      </p:sp>
+      <p:sp>
+        <p:nvSpPr>
+          <p:cNvPr id="13" name="Shape 11"/>
+          <p:cNvSpPr/>
+          <p:nvPr/>
+        </p:nvSpPr>
+        <p:spPr>
+          <a:xfrm>
+            <a:off x="5925312" y="1572768"/>
+            <a:ext cx="265176" cy="0"/>
+          </a:xfrm>
+          <a:prstGeom prst="line">
+            <a:avLst/>
+          </a:prstGeom>
+          <a:noFill/>
+          <a:ln w="25400">
+            <a:solidFill>
+              <a:srgbClr val="1F5FBF"/>
+            </a:solidFill>
+            <a:prstDash val="solid"/>
+            <a:tailEnd type="triangle"/>
+          </a:ln>
+        </p:spPr>
+      </p:sp>
+      <p:sp>
+        <p:nvSpPr>
+          <p:cNvPr id="14" name="Shape 12"/>
+          <p:cNvSpPr/>
+          <p:nvPr/>
+        </p:nvSpPr>
+        <p:spPr>
+          <a:xfrm>
+            <a:off x="6227064" y="914400"/>
+            <a:ext cx="2514600" cy="1325880"/>
+          </a:xfrm>
+          <a:prstGeom prst="roundRect">
+            <a:avLst>
+              <a:gd name="adj" fmla="val 4138"/>
+            </a:avLst>
+          </a:prstGeom>
+          <a:solidFill>
+            <a:srgbClr val="EAF2FF"/>
+          </a:solidFill>
+          <a:ln w="12700">
+            <a:solidFill>
+              <a:srgbClr val="D7DEEA"/>
+            </a:solidFill>
+            <a:prstDash val="solid"/>
+          </a:ln>
+        </p:spPr>
+      </p:sp>
+      <p:sp>
+        <p:nvSpPr>
+          <p:cNvPr id="15" name="Text 13"/>
+          <p:cNvSpPr/>
+          <p:nvPr/>
+        </p:nvSpPr>
+        <p:spPr>
+          <a:xfrm>
+            <a:off x="6391656" y="1060704"/>
+            <a:ext cx="2185416" cy="237744"/>
+          </a:xfrm>
+          <a:prstGeom prst="rect">
+            <a:avLst/>
+          </a:prstGeom>
+          <a:noFill/>
+          <a:ln/>
+        </p:spPr>
+        <p:txBody>
+          <a:bodyPr wrap="square" lIns="0" tIns="0" rIns="0" bIns="0" rtlCol="0" anchor="ctr"/>
+          <a:lstStyle/>
+          <a:p>
+            <a:pPr indent="0" marL="0">
+              <a:buNone/>
+            </a:pPr>
+            <a:r>
+              <a:rPr lang="en-US" sz="1200" b="1" dirty="0">
+                <a:solidFill>
+                  <a:srgbClr val="1F5FBF"/>
+                </a:solidFill>
+              </a:rPr>
+              <a:t>3. MiniProject</a:t>
+            </a:r>
+            <a:endParaRPr lang="en-US" sz="1200" dirty="0"/>
+          </a:p>
+        </p:txBody>
+      </p:sp>
+      <p:sp>
+        <p:nvSpPr>
+          <p:cNvPr id="16" name="Text 14"/>
+          <p:cNvSpPr/>
+          <p:nvPr/>
+        </p:nvSpPr>
+        <p:spPr>
+          <a:xfrm>
+            <a:off x="6391656" y="1389888"/>
+            <a:ext cx="2185416" cy="731520"/>
+          </a:xfrm>
+          <a:prstGeom prst="rect">
+            <a:avLst/>
+          </a:prstGeom>
+          <a:noFill/>
+          <a:ln/>
+        </p:spPr>
+        <p:txBody>
+          <a:bodyPr wrap="square" lIns="381" tIns="381" rIns="381" bIns="381" rtlCol="0" anchor="ctr">
+            <a:normAutofit/>
+          </a:bodyPr>
+          <a:lstStyle/>
+          <a:p>
+            <a:pPr indent="0" marL="0">
+              <a:buNone/>
+            </a:pPr>
+            <a:r>
+              <a:rPr lang="en-US" sz="1070" dirty="0">
+                <a:solidFill>
+                  <a:srgbClr val="182230"/>
+                </a:solidFill>
+              </a:rPr>
+              <a:t>잔액 확인 → 수량 확인</a:t>
+            </a:r>
+            <a:endParaRPr lang="en-US" sz="1070" dirty="0"/>
+          </a:p>
+          <a:p>
+            <a:pPr indent="0" marL="0">
+              <a:buNone/>
+            </a:pPr>
+            <a:r>
+              <a:rPr lang="en-US" sz="1070" dirty="0">
+                <a:solidFill>
+                  <a:srgbClr val="182230"/>
+                </a:solidFill>
+              </a:rPr>
+              <a:t>보유 주식 갱신 → 거래 기록 추가</a:t>
+            </a:r>
+            <a:endParaRPr lang="en-US" sz="1070" dirty="0"/>
+          </a:p>
+        </p:txBody>
+      </p:sp>
+      <p:sp>
+        <p:nvSpPr>
+          <p:cNvPr id="17" name="Shape 15"/>
+          <p:cNvSpPr/>
+          <p:nvPr/>
+        </p:nvSpPr>
+        <p:spPr>
+          <a:xfrm>
+            <a:off x="8741664" y="1572768"/>
+            <a:ext cx="265176" cy="0"/>
+          </a:xfrm>
+          <a:prstGeom prst="line">
+            <a:avLst/>
+          </a:prstGeom>
+          <a:noFill/>
+          <a:ln w="25400">
+            <a:solidFill>
+              <a:srgbClr val="1F5FBF"/>
+            </a:solidFill>
+            <a:prstDash val="solid"/>
+            <a:tailEnd type="triangle"/>
+          </a:ln>
+        </p:spPr>
+      </p:sp>
+      <p:sp>
+        <p:nvSpPr>
+          <p:cNvPr id="18" name="Shape 16"/>
+          <p:cNvSpPr/>
+          <p:nvPr/>
+        </p:nvSpPr>
+        <p:spPr>
+          <a:xfrm>
+            <a:off x="9043416" y="914400"/>
+            <a:ext cx="2514600" cy="1325880"/>
+          </a:xfrm>
+          <a:prstGeom prst="roundRect">
+            <a:avLst>
+              <a:gd name="adj" fmla="val 4138"/>
+            </a:avLst>
+          </a:prstGeom>
+          <a:solidFill>
+            <a:srgbClr val="FFFFFF"/>
+          </a:solidFill>
+          <a:ln w="12700">
+            <a:solidFill>
+              <a:srgbClr val="D7DEEA"/>
+            </a:solidFill>
+            <a:prstDash val="solid"/>
+          </a:ln>
+        </p:spPr>
+      </p:sp>
+      <p:sp>
+        <p:nvSpPr>
+          <p:cNvPr id="19" name="Text 17"/>
+          <p:cNvSpPr/>
+          <p:nvPr/>
+        </p:nvSpPr>
+        <p:spPr>
+          <a:xfrm>
+            <a:off x="9208008" y="1060704"/>
+            <a:ext cx="2185416" cy="237744"/>
+          </a:xfrm>
+          <a:prstGeom prst="rect">
+            <a:avLst/>
+          </a:prstGeom>
+          <a:noFill/>
+          <a:ln/>
+        </p:spPr>
+        <p:txBody>
+          <a:bodyPr wrap="square" lIns="0" tIns="0" rIns="0" bIns="0" rtlCol="0" anchor="ctr"/>
+          <a:lstStyle/>
+          <a:p>
+            <a:pPr indent="0" marL="0">
+              <a:buNone/>
+            </a:pPr>
+            <a:r>
+              <a:rPr lang="en-US" sz="1200" b="1" dirty="0">
+                <a:solidFill>
+                  <a:srgbClr val="1F5FBF"/>
+                </a:solidFill>
+              </a:rPr>
+              <a:t>4. 저장소</a:t>
+            </a:r>
+            <a:endParaRPr lang="en-US" sz="1200" dirty="0"/>
+          </a:p>
+        </p:txBody>
+      </p:sp>
+      <p:sp>
+        <p:nvSpPr>
+          <p:cNvPr id="20" name="Text 18"/>
+          <p:cNvSpPr/>
+          <p:nvPr/>
+        </p:nvSpPr>
+        <p:spPr>
+          <a:xfrm>
+            <a:off x="9208008" y="1389888"/>
+            <a:ext cx="2185416" cy="731520"/>
+          </a:xfrm>
+          <a:prstGeom prst="rect">
+            <a:avLst/>
+          </a:prstGeom>
+          <a:noFill/>
+          <a:ln/>
+        </p:spPr>
+        <p:txBody>
+          <a:bodyPr wrap="square" lIns="381" tIns="381" rIns="381" bIns="381" rtlCol="0" anchor="ctr">
+            <a:normAutofit/>
+          </a:bodyPr>
+          <a:lstStyle/>
+          <a:p>
+            <a:pPr indent="0" marL="0">
+              <a:buNone/>
+            </a:pPr>
+            <a:r>
+              <a:rPr lang="en-US" sz="1070" dirty="0">
+                <a:solidFill>
+                  <a:srgbClr val="182230"/>
+                </a:solidFill>
+              </a:rPr>
+              <a:t>MySQL 저장 시도</a:t>
+            </a:r>
+            <a:endParaRPr lang="en-US" sz="1070" dirty="0"/>
+          </a:p>
+          <a:p>
+            <a:pPr indent="0" marL="0">
+              <a:buNone/>
+            </a:pPr>
+            <a:r>
+              <a:rPr lang="en-US" sz="1070" dirty="0">
+                <a:solidFill>
+                  <a:srgbClr val="182230"/>
+                </a:solidFill>
+              </a:rPr>
+              <a:t>실패 시 로컬 파일 저장소 사용</a:t>
+            </a:r>
+            <a:endParaRPr lang="en-US" sz="1070" dirty="0"/>
+          </a:p>
+        </p:txBody>
+      </p:sp>
+      <p:sp>
+        <p:nvSpPr>
+          <p:cNvPr id="21" name="Text 19"/>
+          <p:cNvSpPr/>
+          <p:nvPr/>
+        </p:nvSpPr>
+        <p:spPr>
+          <a:xfrm>
+            <a:off x="822960" y="3063240"/>
+            <a:ext cx="5166360" cy="219456"/>
           </a:xfrm>
           <a:prstGeom prst="rect">
             <a:avLst/>
@@ -7087,7 +7633,7 @@
                 <a:ea typeface="Malgun Gothic" pitchFamily="34" charset="-122"/>
                 <a:cs typeface="Malgun Gothic" pitchFamily="34" charset="-120"/>
               </a:rPr>
-              <a:t>HTTP 라우팅 - MiniHandler.java</a:t>
+              <a:t>라우팅 핵심 - MiniHandler.java</a:t>
             </a:r>
             <a:endParaRPr lang="en-US" sz="1050" dirty="0"/>
           </a:p>
@@ -7095,18 +7641,18 @@
       </p:sp>
       <p:sp>
         <p:nvSpPr>
-          <p:cNvPr id="7" name="Shape 5"/>
-          <p:cNvSpPr/>
-          <p:nvPr/>
-        </p:nvSpPr>
-        <p:spPr>
-          <a:xfrm>
-            <a:off x="594360" y="1161288"/>
-            <a:ext cx="5303520" cy="1719072"/>
+          <p:cNvPr id="22" name="Shape 20"/>
+          <p:cNvSpPr/>
+          <p:nvPr/>
+        </p:nvSpPr>
+        <p:spPr>
+          <a:xfrm>
+            <a:off x="822960" y="3355848"/>
+            <a:ext cx="5166360" cy="896112"/>
           </a:xfrm>
           <a:prstGeom prst="roundRect">
             <a:avLst>
-              <a:gd name="adj" fmla="val 2128"/>
+              <a:gd name="adj" fmla="val 4082"/>
             </a:avLst>
           </a:prstGeom>
           <a:solidFill>
@@ -7122,14 +7668,14 @@
       </p:sp>
       <p:sp>
         <p:nvSpPr>
-          <p:cNvPr id="8" name="Text 6"/>
-          <p:cNvSpPr/>
-          <p:nvPr/>
-        </p:nvSpPr>
-        <p:spPr>
-          <a:xfrm>
-            <a:off x="731520" y="1289304"/>
-            <a:ext cx="5029200" cy="1481328"/>
+          <p:cNvPr id="23" name="Text 21"/>
+          <p:cNvSpPr/>
+          <p:nvPr/>
+        </p:nvSpPr>
+        <p:spPr>
+          <a:xfrm>
+            <a:off x="960120" y="3483864"/>
+            <a:ext cx="4892040" cy="658368"/>
           </a:xfrm>
           <a:prstGeom prst="rect">
             <a:avLst/>
@@ -7155,7 +7701,7 @@
                 <a:ea typeface="Consolas" pitchFamily="34" charset="-122"/>
                 <a:cs typeface="Consolas" pitchFamily="34" charset="-120"/>
               </a:rPr>
-              <a:t>if ("GET".equals(method) &amp;&amp; "/api/state".equals(path)) {</a:t>
+              <a:t>case "/api/stock/buy" -&gt; project.buyStock(body);</a:t>
             </a:r>
             <a:endParaRPr lang="en-US" sz="690" dirty="0"/>
           </a:p>
@@ -7172,10 +7718,100 @@
                 <a:ea typeface="Consolas" pitchFamily="34" charset="-122"/>
                 <a:cs typeface="Consolas" pitchFamily="34" charset="-120"/>
               </a:rPr>
-              <a:t>    send(exchange, 200, "application/json", project.stateJson());</a:t>
+              <a:t>case "/api/stock/sell" -&gt; project.sellStock(body);</a:t>
             </a:r>
             <a:endParaRPr lang="en-US" sz="690" dirty="0"/>
           </a:p>
+        </p:txBody>
+      </p:sp>
+      <p:sp>
+        <p:nvSpPr>
+          <p:cNvPr id="24" name="Text 22"/>
+          <p:cNvSpPr/>
+          <p:nvPr/>
+        </p:nvSpPr>
+        <p:spPr>
+          <a:xfrm>
+            <a:off x="6263640" y="3063240"/>
+            <a:ext cx="5166360" cy="219456"/>
+          </a:xfrm>
+          <a:prstGeom prst="rect">
+            <a:avLst/>
+          </a:prstGeom>
+          <a:noFill/>
+          <a:ln/>
+        </p:spPr>
+        <p:txBody>
+          <a:bodyPr wrap="square" lIns="0" tIns="0" rIns="0" bIns="0" rtlCol="0" anchor="ctr"/>
+          <a:lstStyle/>
+          <a:p>
+            <a:pPr indent="0" marL="0">
+              <a:buNone/>
+            </a:pPr>
+            <a:r>
+              <a:rPr lang="en-US" sz="1050" b="1" dirty="0">
+                <a:solidFill>
+                  <a:srgbClr val="1F5FBF"/>
+                </a:solidFill>
+                <a:latin typeface="Malgun Gothic" pitchFamily="34" charset="0"/>
+                <a:ea typeface="Malgun Gothic" pitchFamily="34" charset="-122"/>
+                <a:cs typeface="Malgun Gothic" pitchFamily="34" charset="-120"/>
+              </a:rPr>
+              <a:t>매수/저장 핵심 - MiniProject.java</a:t>
+            </a:r>
+            <a:endParaRPr lang="en-US" sz="1050" dirty="0"/>
+          </a:p>
+        </p:txBody>
+      </p:sp>
+      <p:sp>
+        <p:nvSpPr>
+          <p:cNvPr id="25" name="Shape 23"/>
+          <p:cNvSpPr/>
+          <p:nvPr/>
+        </p:nvSpPr>
+        <p:spPr>
+          <a:xfrm>
+            <a:off x="6263640" y="3355848"/>
+            <a:ext cx="5166360" cy="896112"/>
+          </a:xfrm>
+          <a:prstGeom prst="roundRect">
+            <a:avLst>
+              <a:gd name="adj" fmla="val 4082"/>
+            </a:avLst>
+          </a:prstGeom>
+          <a:solidFill>
+            <a:srgbClr val="111827"/>
+          </a:solidFill>
+          <a:ln w="10160">
+            <a:solidFill>
+              <a:srgbClr val="334155"/>
+            </a:solidFill>
+            <a:prstDash val="solid"/>
+          </a:ln>
+        </p:spPr>
+      </p:sp>
+      <p:sp>
+        <p:nvSpPr>
+          <p:cNvPr id="26" name="Text 24"/>
+          <p:cNvSpPr/>
+          <p:nvPr/>
+        </p:nvSpPr>
+        <p:spPr>
+          <a:xfrm>
+            <a:off x="6400800" y="3483864"/>
+            <a:ext cx="4892040" cy="658368"/>
+          </a:xfrm>
+          <a:prstGeom prst="rect">
+            <a:avLst/>
+          </a:prstGeom>
+          <a:noFill/>
+          <a:ln/>
+        </p:spPr>
+        <p:txBody>
+          <a:bodyPr wrap="square" lIns="0" tIns="0" rIns="0" bIns="0" rtlCol="0" anchor="ctr">
+            <a:normAutofit/>
+          </a:bodyPr>
+          <a:lstStyle/>
           <a:p>
             <a:pPr indent="0" marL="0">
               <a:buNone/>
@@ -7189,7 +7825,7 @@
                 <a:ea typeface="Consolas" pitchFamily="34" charset="-122"/>
                 <a:cs typeface="Consolas" pitchFamily="34" charset="-120"/>
               </a:rPr>
-              <a:t>}</a:t>
+              <a:t>member.shares.compute(stockName, (key, share) -&gt; ...);</a:t>
             </a:r>
             <a:endParaRPr lang="en-US" sz="690" dirty="0"/>
           </a:p>
@@ -7206,7 +7842,7 @@
                 <a:ea typeface="Consolas" pitchFamily="34" charset="-122"/>
                 <a:cs typeface="Consolas" pitchFamily="34" charset="-120"/>
               </a:rPr>
-              <a:t>String json = switch (path) {</a:t>
+              <a:t>logs.add(new TradeLog(member.uid, stockName, quantity, total, "구매"));</a:t>
             </a:r>
             <a:endParaRPr lang="en-US" sz="690" dirty="0"/>
           </a:p>
@@ -7223,73 +7859,22 @@
                 <a:ea typeface="Consolas" pitchFamily="34" charset="-122"/>
                 <a:cs typeface="Consolas" pitchFamily="34" charset="-120"/>
               </a:rPr>
-              <a:t>    case "/api/stock/buy" -&gt; project.buyStock(body);</a:t>
+              <a:t>saveDatabase();</a:t>
             </a:r>
             <a:endParaRPr lang="en-US" sz="690" dirty="0"/>
           </a:p>
-          <a:p>
-            <a:pPr indent="0" marL="0">
-              <a:buNone/>
-            </a:pPr>
-            <a:r>
-              <a:rPr lang="en-US" sz="690" dirty="0">
-                <a:solidFill>
-                  <a:srgbClr val="E5E7EB"/>
-                </a:solidFill>
-                <a:latin typeface="Consolas" pitchFamily="34" charset="0"/>
-                <a:ea typeface="Consolas" pitchFamily="34" charset="-122"/>
-                <a:cs typeface="Consolas" pitchFamily="34" charset="-120"/>
-              </a:rPr>
-              <a:t>    case "/api/stock/sell" -&gt; project.sellStock(body);</a:t>
-            </a:r>
-            <a:endParaRPr lang="en-US" sz="690" dirty="0"/>
-          </a:p>
-          <a:p>
-            <a:pPr indent="0" marL="0">
-              <a:buNone/>
-            </a:pPr>
-            <a:r>
-              <a:rPr lang="en-US" sz="690" dirty="0">
-                <a:solidFill>
-                  <a:srgbClr val="E5E7EB"/>
-                </a:solidFill>
-                <a:latin typeface="Consolas" pitchFamily="34" charset="0"/>
-                <a:ea typeface="Consolas" pitchFamily="34" charset="-122"/>
-                <a:cs typeface="Consolas" pitchFamily="34" charset="-120"/>
-              </a:rPr>
-              <a:t>    default -&gt; Json.obj("ok", false, "error", "없는 API");</a:t>
-            </a:r>
-            <a:endParaRPr lang="en-US" sz="690" dirty="0"/>
-          </a:p>
-          <a:p>
-            <a:pPr indent="0" marL="0">
-              <a:buNone/>
-            </a:pPr>
-            <a:r>
-              <a:rPr lang="en-US" sz="690" dirty="0">
-                <a:solidFill>
-                  <a:srgbClr val="E5E7EB"/>
-                </a:solidFill>
-                <a:latin typeface="Consolas" pitchFamily="34" charset="0"/>
-                <a:ea typeface="Consolas" pitchFamily="34" charset="-122"/>
-                <a:cs typeface="Consolas" pitchFamily="34" charset="-120"/>
-              </a:rPr>
-              <a:t>};</a:t>
-            </a:r>
-            <a:endParaRPr lang="en-US" sz="690" dirty="0"/>
-          </a:p>
-        </p:txBody>
-      </p:sp>
-      <p:sp>
-        <p:nvSpPr>
-          <p:cNvPr id="9" name="Text 7"/>
-          <p:cNvSpPr/>
-          <p:nvPr/>
-        </p:nvSpPr>
-        <p:spPr>
-          <a:xfrm>
-            <a:off x="6217920" y="868680"/>
-            <a:ext cx="5349240" cy="219456"/>
+        </p:txBody>
+      </p:sp>
+      <p:sp>
+        <p:nvSpPr>
+          <p:cNvPr id="27" name="Text 25"/>
+          <p:cNvSpPr/>
+          <p:nvPr/>
+        </p:nvSpPr>
+        <p:spPr>
+          <a:xfrm>
+            <a:off x="822960" y="4892040"/>
+            <a:ext cx="10515600" cy="320040"/>
           </a:xfrm>
           <a:prstGeom prst="rect">
             <a:avLst/>
@@ -7305,200 +7890,27 @@
               <a:buNone/>
             </a:pPr>
             <a:r>
-              <a:rPr lang="en-US" sz="1050" b="1" dirty="0">
+              <a:rPr lang="en-US" sz="1350" b="1" dirty="0">
                 <a:solidFill>
                   <a:srgbClr val="1F5FBF"/>
                 </a:solidFill>
-                <a:latin typeface="Malgun Gothic" pitchFamily="34" charset="0"/>
-                <a:ea typeface="Malgun Gothic" pitchFamily="34" charset="-122"/>
-                <a:cs typeface="Malgun Gothic" pitchFamily="34" charset="-120"/>
-              </a:rPr>
-              <a:t>KIS 현재가 조회 - external/KisQuotePoller.java</a:t>
-            </a:r>
-            <a:endParaRPr lang="en-US" sz="1050" dirty="0"/>
-          </a:p>
-        </p:txBody>
-      </p:sp>
-      <p:sp>
-        <p:nvSpPr>
-          <p:cNvPr id="10" name="Shape 8"/>
-          <p:cNvSpPr/>
-          <p:nvPr/>
-        </p:nvSpPr>
-        <p:spPr>
-          <a:xfrm>
-            <a:off x="6217920" y="1161288"/>
-            <a:ext cx="5349240" cy="1719072"/>
-          </a:xfrm>
-          <a:prstGeom prst="roundRect">
-            <a:avLst>
-              <a:gd name="adj" fmla="val 2128"/>
-            </a:avLst>
-          </a:prstGeom>
-          <a:solidFill>
-            <a:srgbClr val="111827"/>
-          </a:solidFill>
-          <a:ln w="10160">
-            <a:solidFill>
-              <a:srgbClr val="334155"/>
-            </a:solidFill>
-            <a:prstDash val="solid"/>
-          </a:ln>
-        </p:spPr>
-      </p:sp>
-      <p:sp>
-        <p:nvSpPr>
-          <p:cNvPr id="11" name="Text 9"/>
-          <p:cNvSpPr/>
-          <p:nvPr/>
-        </p:nvSpPr>
-        <p:spPr>
-          <a:xfrm>
-            <a:off x="6355080" y="1289304"/>
-            <a:ext cx="5074920" cy="1481328"/>
-          </a:xfrm>
-          <a:prstGeom prst="rect">
-            <a:avLst/>
-          </a:prstGeom>
-          <a:noFill/>
-          <a:ln/>
-        </p:spPr>
-        <p:txBody>
-          <a:bodyPr wrap="square" lIns="0" tIns="0" rIns="0" bIns="0" rtlCol="0" anchor="ctr">
-            <a:normAutofit/>
-          </a:bodyPr>
-          <a:lstStyle/>
-          <a:p>
-            <a:pPr indent="0" marL="0">
-              <a:buNone/>
-            </a:pPr>
-            <a:r>
-              <a:rPr lang="en-US" sz="690" dirty="0">
-                <a:solidFill>
-                  <a:srgbClr val="E5E7EB"/>
-                </a:solidFill>
-                <a:latin typeface="Consolas" pitchFamily="34" charset="0"/>
-                <a:ea typeface="Consolas" pitchFamily="34" charset="-122"/>
-                <a:cs typeface="Consolas" pitchFamily="34" charset="-120"/>
-              </a:rPr>
-              <a:t>HttpRequest request = HttpRequest.newBuilder(uri)</a:t>
-            </a:r>
-            <a:endParaRPr lang="en-US" sz="690" dirty="0"/>
-          </a:p>
-          <a:p>
-            <a:pPr indent="0" marL="0">
-              <a:buNone/>
-            </a:pPr>
-            <a:r>
-              <a:rPr lang="en-US" sz="690" dirty="0">
-                <a:solidFill>
-                  <a:srgbClr val="E5E7EB"/>
-                </a:solidFill>
-                <a:latin typeface="Consolas" pitchFamily="34" charset="0"/>
-                <a:ea typeface="Consolas" pitchFamily="34" charset="-122"/>
-                <a:cs typeface="Consolas" pitchFamily="34" charset="-120"/>
-              </a:rPr>
-              <a:t>    .header("authorization", "Bearer " + token)</a:t>
-            </a:r>
-            <a:endParaRPr lang="en-US" sz="690" dirty="0"/>
-          </a:p>
-          <a:p>
-            <a:pPr indent="0" marL="0">
-              <a:buNone/>
-            </a:pPr>
-            <a:r>
-              <a:rPr lang="en-US" sz="690" dirty="0">
-                <a:solidFill>
-                  <a:srgbClr val="E5E7EB"/>
-                </a:solidFill>
-                <a:latin typeface="Consolas" pitchFamily="34" charset="0"/>
-                <a:ea typeface="Consolas" pitchFamily="34" charset="-122"/>
-                <a:cs typeface="Consolas" pitchFamily="34" charset="-120"/>
-              </a:rPr>
-              <a:t>    .header("appkey", config.appKey)</a:t>
-            </a:r>
-            <a:endParaRPr lang="en-US" sz="690" dirty="0"/>
-          </a:p>
-          <a:p>
-            <a:pPr indent="0" marL="0">
-              <a:buNone/>
-            </a:pPr>
-            <a:r>
-              <a:rPr lang="en-US" sz="690" dirty="0">
-                <a:solidFill>
-                  <a:srgbClr val="E5E7EB"/>
-                </a:solidFill>
-                <a:latin typeface="Consolas" pitchFamily="34" charset="0"/>
-                <a:ea typeface="Consolas" pitchFamily="34" charset="-122"/>
-                <a:cs typeface="Consolas" pitchFamily="34" charset="-120"/>
-              </a:rPr>
-              <a:t>    .header("tr_id", "FHKST01010100")</a:t>
-            </a:r>
-            <a:endParaRPr lang="en-US" sz="690" dirty="0"/>
-          </a:p>
-          <a:p>
-            <a:pPr indent="0" marL="0">
-              <a:buNone/>
-            </a:pPr>
-            <a:r>
-              <a:rPr lang="en-US" sz="690" dirty="0">
-                <a:solidFill>
-                  <a:srgbClr val="E5E7EB"/>
-                </a:solidFill>
-                <a:latin typeface="Consolas" pitchFamily="34" charset="0"/>
-                <a:ea typeface="Consolas" pitchFamily="34" charset="-122"/>
-                <a:cs typeface="Consolas" pitchFamily="34" charset="-120"/>
-              </a:rPr>
-              <a:t>    .GET()</a:t>
-            </a:r>
-            <a:endParaRPr lang="en-US" sz="690" dirty="0"/>
-          </a:p>
-          <a:p>
-            <a:pPr indent="0" marL="0">
-              <a:buNone/>
-            </a:pPr>
-            <a:r>
-              <a:rPr lang="en-US" sz="690" dirty="0">
-                <a:solidFill>
-                  <a:srgbClr val="E5E7EB"/>
-                </a:solidFill>
-                <a:latin typeface="Consolas" pitchFamily="34" charset="0"/>
-                <a:ea typeface="Consolas" pitchFamily="34" charset="-122"/>
-                <a:cs typeface="Consolas" pitchFamily="34" charset="-120"/>
-              </a:rPr>
-              <a:t>    .build();</a:t>
-            </a:r>
-            <a:endParaRPr lang="en-US" sz="690" dirty="0"/>
-          </a:p>
-          <a:p>
-            <a:pPr indent="0" marL="0">
-              <a:buNone/>
-            </a:pPr>
-            <a:r>
-              <a:rPr lang="en-US" sz="690" dirty="0">
-                <a:solidFill>
-                  <a:srgbClr val="E5E7EB"/>
-                </a:solidFill>
-                <a:latin typeface="Consolas" pitchFamily="34" charset="0"/>
-                <a:ea typeface="Consolas" pitchFamily="34" charset="-122"/>
-                <a:cs typeface="Consolas" pitchFamily="34" charset="-120"/>
-              </a:rPr>
-              <a:t>HttpResponse&lt;String&gt; response = client.send(request, BodyHandlers.ofString());</a:t>
-            </a:r>
-            <a:endParaRPr lang="en-US" sz="690" dirty="0"/>
-          </a:p>
-        </p:txBody>
-      </p:sp>
-      <p:sp>
-        <p:nvSpPr>
-          <p:cNvPr id="12" name="Text 10"/>
-          <p:cNvSpPr/>
-          <p:nvPr/>
-        </p:nvSpPr>
-        <p:spPr>
-          <a:xfrm>
-            <a:off x="594360" y="3246120"/>
-            <a:ext cx="5303520" cy="219456"/>
+              </a:rPr>
+              <a:t>발표에서는 코드 전체를 읽기보다, 웹 요청이 서비스 로직을 거쳐 저장소까지 이어지는 흐름을 설명한다.</a:t>
+            </a:r>
+            <a:endParaRPr lang="en-US" sz="1350" dirty="0"/>
+          </a:p>
+        </p:txBody>
+      </p:sp>
+      <p:sp>
+        <p:nvSpPr>
+          <p:cNvPr id="28" name="Text 26"/>
+          <p:cNvSpPr/>
+          <p:nvPr/>
+        </p:nvSpPr>
+        <p:spPr>
+          <a:xfrm>
+            <a:off x="822960" y="5394960"/>
+            <a:ext cx="10515600" cy="274320"/>
           </a:xfrm>
           <a:prstGeom prst="rect">
             <a:avLst/>
@@ -7514,449 +7926,14 @@
               <a:buNone/>
             </a:pPr>
             <a:r>
-              <a:rPr lang="en-US" sz="1050" b="1" dirty="0">
-                <a:solidFill>
-                  <a:srgbClr val="1F5FBF"/>
-                </a:solidFill>
-                <a:latin typeface="Malgun Gothic" pitchFamily="34" charset="0"/>
-                <a:ea typeface="Malgun Gothic" pitchFamily="34" charset="-122"/>
-                <a:cs typeface="Malgun Gothic" pitchFamily="34" charset="-120"/>
-              </a:rPr>
-              <a:t>매수 처리 - MiniProject.java</a:t>
-            </a:r>
-            <a:endParaRPr lang="en-US" sz="1050" dirty="0"/>
-          </a:p>
-        </p:txBody>
-      </p:sp>
-      <p:sp>
-        <p:nvSpPr>
-          <p:cNvPr id="13" name="Shape 11"/>
-          <p:cNvSpPr/>
-          <p:nvPr/>
-        </p:nvSpPr>
-        <p:spPr>
-          <a:xfrm>
-            <a:off x="594360" y="3538728"/>
-            <a:ext cx="5303520" cy="1947672"/>
-          </a:xfrm>
-          <a:prstGeom prst="roundRect">
-            <a:avLst>
-              <a:gd name="adj" fmla="val 1878"/>
-            </a:avLst>
-          </a:prstGeom>
-          <a:solidFill>
-            <a:srgbClr val="111827"/>
-          </a:solidFill>
-          <a:ln w="10160">
-            <a:solidFill>
-              <a:srgbClr val="334155"/>
-            </a:solidFill>
-            <a:prstDash val="solid"/>
-          </a:ln>
-        </p:spPr>
-      </p:sp>
-      <p:sp>
-        <p:nvSpPr>
-          <p:cNvPr id="14" name="Text 12"/>
-          <p:cNvSpPr/>
-          <p:nvPr/>
-        </p:nvSpPr>
-        <p:spPr>
-          <a:xfrm>
-            <a:off x="731520" y="3666744"/>
-            <a:ext cx="5029200" cy="1709928"/>
-          </a:xfrm>
-          <a:prstGeom prst="rect">
-            <a:avLst/>
-          </a:prstGeom>
-          <a:noFill/>
-          <a:ln/>
-        </p:spPr>
-        <p:txBody>
-          <a:bodyPr wrap="square" lIns="0" tIns="0" rIns="0" bIns="0" rtlCol="0" anchor="ctr">
-            <a:normAutofit/>
-          </a:bodyPr>
-          <a:lstStyle/>
-          <a:p>
-            <a:pPr indent="0" marL="0">
-              <a:buNone/>
-            </a:pPr>
-            <a:r>
-              <a:rPr lang="en-US" sz="690" dirty="0">
-                <a:solidFill>
-                  <a:srgbClr val="E5E7EB"/>
-                </a:solidFill>
-                <a:latin typeface="Consolas" pitchFamily="34" charset="0"/>
-                <a:ea typeface="Consolas" pitchFamily="34" charset="-122"/>
-                <a:cs typeface="Consolas" pitchFamily="34" charset="-120"/>
-              </a:rPr>
-              <a:t>Member member = defaultMember();</a:t>
-            </a:r>
-            <a:endParaRPr lang="en-US" sz="690" dirty="0"/>
-          </a:p>
-          <a:p>
-            <a:pPr indent="0" marL="0">
-              <a:buNone/>
-            </a:pPr>
-            <a:r>
-              <a:rPr lang="en-US" sz="690" dirty="0">
-                <a:solidFill>
-                  <a:srgbClr val="E5E7EB"/>
-                </a:solidFill>
-                <a:latin typeface="Consolas" pitchFamily="34" charset="0"/>
-                <a:ea typeface="Consolas" pitchFamily="34" charset="-122"/>
-                <a:cs typeface="Consolas" pitchFamily="34" charset="-120"/>
-              </a:rPr>
-              <a:t>Stock stock = member.stocks.get(stockName);</a:t>
-            </a:r>
-            <a:endParaRPr lang="en-US" sz="690" dirty="0"/>
-          </a:p>
-          <a:p>
-            <a:pPr indent="0" marL="0">
-              <a:buNone/>
-            </a:pPr>
-            <a:r>
-              <a:rPr lang="en-US" sz="690" dirty="0">
-                <a:solidFill>
-                  <a:srgbClr val="E5E7EB"/>
-                </a:solidFill>
-                <a:latin typeface="Consolas" pitchFamily="34" charset="0"/>
-                <a:ea typeface="Consolas" pitchFamily="34" charset="-122"/>
-                <a:cs typeface="Consolas" pitchFamily="34" charset="-120"/>
-              </a:rPr>
-              <a:t>long total = (long) stock.price * quantity;</a:t>
-            </a:r>
-            <a:endParaRPr lang="en-US" sz="690" dirty="0"/>
-          </a:p>
-          <a:p>
-            <a:pPr indent="0" marL="0">
-              <a:buNone/>
-            </a:pPr>
-            <a:r>
-              <a:rPr lang="en-US" sz="690" dirty="0">
-                <a:solidFill>
-                  <a:srgbClr val="E5E7EB"/>
-                </a:solidFill>
-                <a:latin typeface="Consolas" pitchFamily="34" charset="0"/>
-                <a:ea typeface="Consolas" pitchFamily="34" charset="-122"/>
-                <a:cs typeface="Consolas" pitchFamily="34" charset="-120"/>
-              </a:rPr>
-              <a:t>if (member.balance &lt; total) return Json.obj("ok", false);</a:t>
-            </a:r>
-            <a:endParaRPr lang="en-US" sz="690" dirty="0"/>
-          </a:p>
-          <a:p>
-            <a:pPr indent="0" marL="0">
-              <a:buNone/>
-            </a:pPr>
-            <a:r>
-              <a:rPr lang="en-US" sz="690" dirty="0">
-                <a:solidFill>
-                  <a:srgbClr val="E5E7EB"/>
-                </a:solidFill>
-                <a:latin typeface="Consolas" pitchFamily="34" charset="0"/>
-                <a:ea typeface="Consolas" pitchFamily="34" charset="-122"/>
-                <a:cs typeface="Consolas" pitchFamily="34" charset="-120"/>
-              </a:rPr>
-              <a:t>member.balance -= total;</a:t>
-            </a:r>
-            <a:endParaRPr lang="en-US" sz="690" dirty="0"/>
-          </a:p>
-          <a:p>
-            <a:pPr indent="0" marL="0">
-              <a:buNone/>
-            </a:pPr>
-            <a:r>
-              <a:rPr lang="en-US" sz="690" dirty="0">
-                <a:solidFill>
-                  <a:srgbClr val="E5E7EB"/>
-                </a:solidFill>
-                <a:latin typeface="Consolas" pitchFamily="34" charset="0"/>
-                <a:ea typeface="Consolas" pitchFamily="34" charset="-122"/>
-                <a:cs typeface="Consolas" pitchFamily="34" charset="-120"/>
-              </a:rPr>
-              <a:t>member.shares.put(stockName, share.buy(quantity, total));</a:t>
-            </a:r>
-            <a:endParaRPr lang="en-US" sz="690" dirty="0"/>
-          </a:p>
-          <a:p>
-            <a:pPr indent="0" marL="0">
-              <a:buNone/>
-            </a:pPr>
-            <a:r>
-              <a:rPr lang="en-US" sz="690" dirty="0">
-                <a:solidFill>
-                  <a:srgbClr val="E5E7EB"/>
-                </a:solidFill>
-                <a:latin typeface="Consolas" pitchFamily="34" charset="0"/>
-                <a:ea typeface="Consolas" pitchFamily="34" charset="-122"/>
-                <a:cs typeface="Consolas" pitchFamily="34" charset="-120"/>
-              </a:rPr>
-              <a:t>logs.add(new TradeLog(member.uid, stockName, quantity, total, "구매"));</a:t>
-            </a:r>
-            <a:endParaRPr lang="en-US" sz="690" dirty="0"/>
-          </a:p>
-          <a:p>
-            <a:pPr indent="0" marL="0">
-              <a:buNone/>
-            </a:pPr>
-            <a:r>
-              <a:rPr lang="en-US" sz="690" dirty="0">
-                <a:solidFill>
-                  <a:srgbClr val="E5E7EB"/>
-                </a:solidFill>
-                <a:latin typeface="Consolas" pitchFamily="34" charset="0"/>
-                <a:ea typeface="Consolas" pitchFamily="34" charset="-122"/>
-                <a:cs typeface="Consolas" pitchFamily="34" charset="-120"/>
-              </a:rPr>
-              <a:t>saveDatabase();</a:t>
-            </a:r>
-            <a:endParaRPr lang="en-US" sz="690" dirty="0"/>
-          </a:p>
-        </p:txBody>
-      </p:sp>
-      <p:sp>
-        <p:nvSpPr>
-          <p:cNvPr id="15" name="Text 13"/>
-          <p:cNvSpPr/>
-          <p:nvPr/>
-        </p:nvSpPr>
-        <p:spPr>
-          <a:xfrm>
-            <a:off x="6217920" y="3246120"/>
-            <a:ext cx="5349240" cy="219456"/>
-          </a:xfrm>
-          <a:prstGeom prst="rect">
-            <a:avLst/>
-          </a:prstGeom>
-          <a:noFill/>
-          <a:ln/>
-        </p:spPr>
-        <p:txBody>
-          <a:bodyPr wrap="square" lIns="0" tIns="0" rIns="0" bIns="0" rtlCol="0" anchor="ctr"/>
-          <a:lstStyle/>
-          <a:p>
-            <a:pPr indent="0" marL="0">
-              <a:buNone/>
-            </a:pPr>
-            <a:r>
-              <a:rPr lang="en-US" sz="1050" b="1" dirty="0">
-                <a:solidFill>
-                  <a:srgbClr val="1F5FBF"/>
-                </a:solidFill>
-                <a:latin typeface="Malgun Gothic" pitchFamily="34" charset="0"/>
-                <a:ea typeface="Malgun Gothic" pitchFamily="34" charset="-122"/>
-                <a:cs typeface="Malgun Gothic" pitchFamily="34" charset="-120"/>
-              </a:rPr>
-              <a:t>MySQL 저장 - repository/MySqlDatabase.java</a:t>
-            </a:r>
-            <a:endParaRPr lang="en-US" sz="1050" dirty="0"/>
-          </a:p>
-        </p:txBody>
-      </p:sp>
-      <p:sp>
-        <p:nvSpPr>
-          <p:cNvPr id="16" name="Shape 14"/>
-          <p:cNvSpPr/>
-          <p:nvPr/>
-        </p:nvSpPr>
-        <p:spPr>
-          <a:xfrm>
-            <a:off x="6217920" y="3538728"/>
-            <a:ext cx="5349240" cy="1947672"/>
-          </a:xfrm>
-          <a:prstGeom prst="roundRect">
-            <a:avLst>
-              <a:gd name="adj" fmla="val 1878"/>
-            </a:avLst>
-          </a:prstGeom>
-          <a:solidFill>
-            <a:srgbClr val="111827"/>
-          </a:solidFill>
-          <a:ln w="10160">
-            <a:solidFill>
-              <a:srgbClr val="334155"/>
-            </a:solidFill>
-            <a:prstDash val="solid"/>
-          </a:ln>
-        </p:spPr>
-      </p:sp>
-      <p:sp>
-        <p:nvSpPr>
-          <p:cNvPr id="17" name="Text 15"/>
-          <p:cNvSpPr/>
-          <p:nvPr/>
-        </p:nvSpPr>
-        <p:spPr>
-          <a:xfrm>
-            <a:off x="6355080" y="3666744"/>
-            <a:ext cx="5074920" cy="1709928"/>
-          </a:xfrm>
-          <a:prstGeom prst="rect">
-            <a:avLst/>
-          </a:prstGeom>
-          <a:noFill/>
-          <a:ln/>
-        </p:spPr>
-        <p:txBody>
-          <a:bodyPr wrap="square" lIns="0" tIns="0" rIns="0" bIns="0" rtlCol="0" anchor="ctr">
-            <a:normAutofit/>
-          </a:bodyPr>
-          <a:lstStyle/>
-          <a:p>
-            <a:pPr indent="0" marL="0">
-              <a:buNone/>
-            </a:pPr>
-            <a:r>
-              <a:rPr lang="en-US" sz="690" dirty="0">
-                <a:solidFill>
-                  <a:srgbClr val="E5E7EB"/>
-                </a:solidFill>
-                <a:latin typeface="Consolas" pitchFamily="34" charset="0"/>
-                <a:ea typeface="Consolas" pitchFamily="34" charset="-122"/>
-                <a:cs typeface="Consolas" pitchFamily="34" charset="-120"/>
-              </a:rPr>
-              <a:t>try (Connection con = DriverManager.getConnection(url, user, password)) {</a:t>
-            </a:r>
-            <a:endParaRPr lang="en-US" sz="690" dirty="0"/>
-          </a:p>
-          <a:p>
-            <a:pPr indent="0" marL="0">
-              <a:buNone/>
-            </a:pPr>
-            <a:r>
-              <a:rPr lang="en-US" sz="690" dirty="0">
-                <a:solidFill>
-                  <a:srgbClr val="E5E7EB"/>
-                </a:solidFill>
-                <a:latin typeface="Consolas" pitchFamily="34" charset="0"/>
-                <a:ea typeface="Consolas" pitchFamily="34" charset="-122"/>
-                <a:cs typeface="Consolas" pitchFamily="34" charset="-120"/>
-              </a:rPr>
-              <a:t>    con.setAutoCommit(false);</a:t>
-            </a:r>
-            <a:endParaRPr lang="en-US" sz="690" dirty="0"/>
-          </a:p>
-          <a:p>
-            <a:pPr indent="0" marL="0">
-              <a:buNone/>
-            </a:pPr>
-            <a:r>
-              <a:rPr lang="en-US" sz="690" dirty="0">
-                <a:solidFill>
-                  <a:srgbClr val="E5E7EB"/>
-                </a:solidFill>
-                <a:latin typeface="Consolas" pitchFamily="34" charset="0"/>
-                <a:ea typeface="Consolas" pitchFamily="34" charset="-122"/>
-                <a:cs typeface="Consolas" pitchFamily="34" charset="-120"/>
-              </a:rPr>
-              <a:t>    insertMembers(con, members);</a:t>
-            </a:r>
-            <a:endParaRPr lang="en-US" sz="690" dirty="0"/>
-          </a:p>
-          <a:p>
-            <a:pPr indent="0" marL="0">
-              <a:buNone/>
-            </a:pPr>
-            <a:r>
-              <a:rPr lang="en-US" sz="690" dirty="0">
-                <a:solidFill>
-                  <a:srgbClr val="E5E7EB"/>
-                </a:solidFill>
-                <a:latin typeface="Consolas" pitchFamily="34" charset="0"/>
-                <a:ea typeface="Consolas" pitchFamily="34" charset="-122"/>
-                <a:cs typeface="Consolas" pitchFamily="34" charset="-120"/>
-              </a:rPr>
-              <a:t>    insertShares(con, members);</a:t>
-            </a:r>
-            <a:endParaRPr lang="en-US" sz="690" dirty="0"/>
-          </a:p>
-          <a:p>
-            <a:pPr indent="0" marL="0">
-              <a:buNone/>
-            </a:pPr>
-            <a:r>
-              <a:rPr lang="en-US" sz="690" dirty="0">
-                <a:solidFill>
-                  <a:srgbClr val="E5E7EB"/>
-                </a:solidFill>
-                <a:latin typeface="Consolas" pitchFamily="34" charset="0"/>
-                <a:ea typeface="Consolas" pitchFamily="34" charset="-122"/>
-                <a:cs typeface="Consolas" pitchFamily="34" charset="-120"/>
-              </a:rPr>
-              <a:t>    insertTradeLogs(con, logs);</a:t>
-            </a:r>
-            <a:endParaRPr lang="en-US" sz="690" dirty="0"/>
-          </a:p>
-          <a:p>
-            <a:pPr indent="0" marL="0">
-              <a:buNone/>
-            </a:pPr>
-            <a:r>
-              <a:rPr lang="en-US" sz="690" dirty="0">
-                <a:solidFill>
-                  <a:srgbClr val="E5E7EB"/>
-                </a:solidFill>
-                <a:latin typeface="Consolas" pitchFamily="34" charset="0"/>
-                <a:ea typeface="Consolas" pitchFamily="34" charset="-122"/>
-                <a:cs typeface="Consolas" pitchFamily="34" charset="-120"/>
-              </a:rPr>
-              <a:t>    con.commit();</a:t>
-            </a:r>
-            <a:endParaRPr lang="en-US" sz="690" dirty="0"/>
-          </a:p>
-          <a:p>
-            <a:pPr indent="0" marL="0">
-              <a:buNone/>
-            </a:pPr>
-            <a:r>
-              <a:rPr lang="en-US" sz="690" dirty="0">
-                <a:solidFill>
-                  <a:srgbClr val="E5E7EB"/>
-                </a:solidFill>
-                <a:latin typeface="Consolas" pitchFamily="34" charset="0"/>
-                <a:ea typeface="Consolas" pitchFamily="34" charset="-122"/>
-                <a:cs typeface="Consolas" pitchFamily="34" charset="-120"/>
-              </a:rPr>
-              <a:t>}</a:t>
-            </a:r>
-            <a:endParaRPr lang="en-US" sz="690" dirty="0"/>
-          </a:p>
-        </p:txBody>
-      </p:sp>
-      <p:sp>
-        <p:nvSpPr>
-          <p:cNvPr id="18" name="Text 16"/>
-          <p:cNvSpPr/>
-          <p:nvPr/>
-        </p:nvSpPr>
-        <p:spPr>
-          <a:xfrm>
-            <a:off x="685800" y="5760720"/>
-            <a:ext cx="10881360" cy="274320"/>
-          </a:xfrm>
-          <a:prstGeom prst="rect">
-            <a:avLst/>
-          </a:prstGeom>
-          <a:noFill/>
-          <a:ln/>
-        </p:spPr>
-        <p:txBody>
-          <a:bodyPr wrap="square" lIns="0" tIns="0" rIns="0" bIns="0" rtlCol="0" anchor="ctr"/>
-          <a:lstStyle/>
-          <a:p>
-            <a:pPr indent="0" marL="0">
-              <a:buNone/>
-            </a:pPr>
-            <a:r>
-              <a:rPr lang="en-US" sz="1250" b="1" dirty="0">
-                <a:solidFill>
-                  <a:srgbClr val="182230"/>
-                </a:solidFill>
-              </a:rPr>
-              <a:t>발표에서는 전체 코드를 읽기보다 요청 처리, 외부 API, 거래 처리, 저장 흐름이 실제로 연결되어 있다는 점을 보여준다.</a:t>
-            </a:r>
-            <a:endParaRPr lang="en-US" sz="1250" dirty="0"/>
+              <a:rPr lang="en-US" sz="1180" dirty="0">
+                <a:solidFill>
+                  <a:srgbClr val="667085"/>
+                </a:solidFill>
+              </a:rPr>
+              <a:t>실제 상세 구현은 GitHub의 MiniHandler.java, MiniProject.java, repository/MySqlDatabase.java에서 확인할 수 있다.</a:t>
+            </a:r>
+            <a:endParaRPr lang="en-US" sz="1180" dirty="0"/>
           </a:p>
         </p:txBody>
       </p:sp>
@@ -8482,7 +8459,7 @@
                   <a:srgbClr val="1F5FBF"/>
                 </a:solidFill>
               </a:rPr>
-              <a:t>구조 개선</a:t>
+              <a:t>구조 정리 완료</a:t>
             </a:r>
             <a:endParaRPr lang="en-US" sz="1200" dirty="0"/>
           </a:p>
@@ -8520,7 +8497,7 @@
                   <a:srgbClr val="182230"/>
                 </a:solidFill>
               </a:rPr>
-              <a:t>src/main/java 아래 app/controller/service/domain/repository/external/view/util 패키지로 분리</a:t>
+              <a:t>src/main/java 아래 app/controller/service/domain/repository/external/view/util 패키지로 물리적 분리</a:t>
             </a:r>
             <a:endParaRPr lang="en-US" sz="1070" dirty="0"/>
           </a:p>
@@ -8684,7 +8661,7 @@
                   <a:srgbClr val="1F5FBF"/>
                 </a:solidFill>
               </a:rPr>
-              <a:t>문서 정합성</a:t>
+              <a:t>문서 정합성 완료</a:t>
             </a:r>
             <a:endParaRPr lang="en-US" sz="1200" dirty="0"/>
           </a:p>
@@ -8722,7 +8699,7 @@
                   <a:srgbClr val="182230"/>
                 </a:solidFill>
               </a:rPr>
-              <a:t>PPT, 보고서, README가 실제 코드 구조와 같은 용어를 쓰도록 정리</a:t>
+              <a:t>PPT, 보고서, README가 실제 코드 구조와 같은 용어를 쓰도록 최종 정리</a:t>
             </a:r>
             <a:endParaRPr lang="en-US" sz="1070" dirty="0"/>
           </a:p>
@@ -9136,7 +9113,7 @@
                   <a:srgbClr val="182230"/>
                 </a:solidFill>
               </a:rPr>
-              <a:t>0~10초</a:t>
+              <a:t>0~4초</a:t>
             </a:r>
             <a:endParaRPr lang="en-US" sz="920" dirty="0"/>
           </a:p>
@@ -9325,7 +9302,7 @@
                   <a:srgbClr val="182230"/>
                 </a:solidFill>
               </a:rPr>
-              <a:t>10~25초</a:t>
+              <a:t>4~8초</a:t>
             </a:r>
             <a:endParaRPr lang="en-US" sz="920" dirty="0"/>
           </a:p>
@@ -9514,7 +9491,7 @@
                   <a:srgbClr val="182230"/>
                 </a:solidFill>
               </a:rPr>
-              <a:t>25~40초</a:t>
+              <a:t>8~12초</a:t>
             </a:r>
             <a:endParaRPr lang="en-US" sz="920" dirty="0"/>
           </a:p>
@@ -9703,7 +9680,7 @@
                   <a:srgbClr val="182230"/>
                 </a:solidFill>
               </a:rPr>
-              <a:t>40~55초</a:t>
+              <a:t>12~16초</a:t>
             </a:r>
             <a:endParaRPr lang="en-US" sz="920" dirty="0"/>
           </a:p>

</xml_diff>

<commit_message>
Final submission consistency pass
</commit_message>
<xml_diff>
--- a/deliverables/Java_모의주식투자_발표자료_최종정합본.pptx
+++ b/deliverables/Java_모의주식투자_발표자료_최종정합본.pptx
@@ -6830,7 +6830,7 @@
                 <a:ea typeface="Malgun Gothic" pitchFamily="34" charset="-122"/>
                 <a:cs typeface="Malgun Gothic" pitchFamily="34" charset="-120"/>
               </a:rPr>
-              <a:t>ConcurrentHashMap: 회원/종목 상태 동시 접근 처리</a:t>
+              <a:t>ConcurrentHashMap: 모의 계좌/종목 상태 동시 접근 처리</a:t>
             </a:r>
             <a:endParaRPr lang="en-US" sz="1400" dirty="0"/>
           </a:p>
@@ -14321,7 +14321,7 @@
                   <a:srgbClr val="182230"/>
                 </a:solidFill>
               </a:rPr>
-              <a:t>회원/종목/거래 상태 관리</a:t>
+              <a:t>모의 계좌/종목/거래 상태 관리</a:t>
             </a:r>
             <a:endParaRPr lang="en-US" sz="1070" dirty="0"/>
           </a:p>
@@ -15844,7 +15844,7 @@
                   <a:srgbClr val="182230"/>
                 </a:solidFill>
               </a:rPr>
-              <a:t>회원, 종목, 보유 수량, 거래 내역 표현</a:t>
+              <a:t>모의 계좌, 종목, 보유 수량, 거래 내역 표현</a:t>
             </a:r>
             <a:endParaRPr lang="en-US" sz="920" dirty="0"/>
           </a:p>

</xml_diff>

<commit_message>
Add actual UI screenshots to deliverables
</commit_message>
<xml_diff>
--- a/deliverables/Java_모의주식투자_발표자료_최종정합본.pptx
+++ b/deliverables/Java_모의주식투자_발표자료_최종정합본.pptx
@@ -3783,16 +3783,16 @@
         </p:nvSpPr>
         <p:spPr>
           <a:xfrm>
-            <a:off x="594360" y="914400"/>
-            <a:ext cx="2743200" cy="960120"/>
+            <a:off x="502920" y="841248"/>
+            <a:ext cx="3246120" cy="5303520"/>
           </a:xfrm>
           <a:prstGeom prst="roundRect">
             <a:avLst>
-              <a:gd name="adj" fmla="val 5714"/>
+              <a:gd name="adj" fmla="val 1127"/>
             </a:avLst>
           </a:prstGeom>
           <a:solidFill>
-            <a:srgbClr val="EAF2FF"/>
+            <a:srgbClr val="FFFFFF"/>
           </a:solidFill>
           <a:ln w="12700">
             <a:solidFill>
@@ -3802,16 +3802,40 @@
           </a:ln>
         </p:spPr>
       </p:sp>
-      <p:sp>
-        <p:nvSpPr>
-          <p:cNvPr id="6" name="Text 4"/>
-          <p:cNvSpPr/>
-          <p:nvPr/>
-        </p:nvSpPr>
-        <p:spPr>
-          <a:xfrm>
-            <a:off x="758952" y="1060704"/>
-            <a:ext cx="2414016" cy="237744"/>
+      <p:pic>
+        <p:nvPicPr>
+          <p:cNvPr id="6" name="Image 0" descr="C:\Users\user\Documents\Codex\2026-05-19\100\deliverables\ui-screenshots\ui-crop-01-market.png">    </p:cNvPr>
+          <p:cNvPicPr>
+            <a:picLocks noChangeAspect="1"/>
+          </p:cNvPicPr>
+          <p:nvPr/>
+        </p:nvPicPr>
+        <p:blipFill>
+          <a:blip r:embed="rId1"/>
+          <a:stretch>
+            <a:fillRect/>
+          </a:stretch>
+        </p:blipFill>
+        <p:spPr>
+          <a:xfrm>
+            <a:off x="566928" y="960120"/>
+            <a:ext cx="3108960" cy="5084064"/>
+          </a:xfrm>
+          <a:prstGeom prst="rect">
+            <a:avLst/>
+          </a:prstGeom>
+        </p:spPr>
+      </p:pic>
+      <p:sp>
+        <p:nvSpPr>
+          <p:cNvPr id="7" name="Text 4"/>
+          <p:cNvSpPr/>
+          <p:nvPr/>
+        </p:nvSpPr>
+        <p:spPr>
+          <a:xfrm>
+            <a:off x="640080" y="6126480"/>
+            <a:ext cx="2971800" cy="219456"/>
           </a:xfrm>
           <a:prstGeom prst="rect">
             <a:avLst/>
@@ -3823,40 +3847,127 @@
           <a:bodyPr wrap="square" lIns="0" tIns="0" rIns="0" bIns="0" rtlCol="0" anchor="ctr"/>
           <a:lstStyle/>
           <a:p>
-            <a:pPr indent="0" marL="0">
-              <a:buNone/>
-            </a:pPr>
-            <a:r>
-              <a:rPr lang="en-US" sz="1200" b="1" dirty="0">
+            <a:pPr algn="ctr" indent="0" marL="0">
+              <a:buNone/>
+            </a:pPr>
+            <a:r>
+              <a:rPr lang="en-US" sz="920" b="1" dirty="0">
                 <a:solidFill>
                   <a:srgbClr val="1F5FBF"/>
                 </a:solidFill>
               </a:rPr>
-              <a:t>상단 요약</a:t>
-            </a:r>
-            <a:endParaRPr lang="en-US" sz="1200" dirty="0"/>
-          </a:p>
-        </p:txBody>
-      </p:sp>
-      <p:sp>
-        <p:nvSpPr>
-          <p:cNvPr id="7" name="Text 5"/>
-          <p:cNvSpPr/>
-          <p:nvPr/>
-        </p:nvSpPr>
-        <p:spPr>
-          <a:xfrm>
-            <a:off x="758952" y="1389888"/>
-            <a:ext cx="2414016" cy="365760"/>
-          </a:xfrm>
-          <a:prstGeom prst="rect">
-            <a:avLst/>
-          </a:prstGeom>
-          <a:noFill/>
-          <a:ln/>
-        </p:spPr>
-        <p:txBody>
-          <a:bodyPr wrap="square" lIns="381" tIns="381" rIns="381" bIns="381" rtlCol="0" anchor="ctr">
+              <a:t>시장 시세 / 검색 / 페이지</a:t>
+            </a:r>
+            <a:endParaRPr lang="en-US" sz="920" dirty="0"/>
+          </a:p>
+        </p:txBody>
+      </p:sp>
+      <p:sp>
+        <p:nvSpPr>
+          <p:cNvPr id="8" name="Shape 5"/>
+          <p:cNvSpPr/>
+          <p:nvPr/>
+        </p:nvSpPr>
+        <p:spPr>
+          <a:xfrm>
+            <a:off x="3977640" y="841248"/>
+            <a:ext cx="7635240" cy="3429000"/>
+          </a:xfrm>
+          <a:prstGeom prst="roundRect">
+            <a:avLst>
+              <a:gd name="adj" fmla="val 1067"/>
+            </a:avLst>
+          </a:prstGeom>
+          <a:solidFill>
+            <a:srgbClr val="FFFFFF"/>
+          </a:solidFill>
+          <a:ln w="12700">
+            <a:solidFill>
+              <a:srgbClr val="D7DEEA"/>
+            </a:solidFill>
+            <a:prstDash val="solid"/>
+          </a:ln>
+        </p:spPr>
+      </p:sp>
+      <p:pic>
+        <p:nvPicPr>
+          <p:cNvPr id="9" name="Image 1" descr="C:\Users\user\Documents\Codex\2026-05-19\100\deliverables\ui-screenshots\ui-crop-02-detail-order.png">    </p:cNvPr>
+          <p:cNvPicPr>
+            <a:picLocks noChangeAspect="1"/>
+          </p:cNvPicPr>
+          <p:nvPr/>
+        </p:nvPicPr>
+        <p:blipFill>
+          <a:blip r:embed="rId2"/>
+          <a:stretch>
+            <a:fillRect/>
+          </a:stretch>
+        </p:blipFill>
+        <p:spPr>
+          <a:xfrm>
+            <a:off x="4096512" y="960120"/>
+            <a:ext cx="4983480" cy="3383280"/>
+          </a:xfrm>
+          <a:prstGeom prst="rect">
+            <a:avLst/>
+          </a:prstGeom>
+        </p:spPr>
+      </p:pic>
+      <p:sp>
+        <p:nvSpPr>
+          <p:cNvPr id="10" name="Text 6"/>
+          <p:cNvSpPr/>
+          <p:nvPr/>
+        </p:nvSpPr>
+        <p:spPr>
+          <a:xfrm>
+            <a:off x="4160520" y="4315968"/>
+            <a:ext cx="4800600" cy="219456"/>
+          </a:xfrm>
+          <a:prstGeom prst="rect">
+            <a:avLst/>
+          </a:prstGeom>
+          <a:noFill/>
+          <a:ln/>
+        </p:spPr>
+        <p:txBody>
+          <a:bodyPr wrap="square" lIns="0" tIns="0" rIns="0" bIns="0" rtlCol="0" anchor="ctr"/>
+          <a:lstStyle/>
+          <a:p>
+            <a:pPr algn="ctr" indent="0" marL="0">
+              <a:buNone/>
+            </a:pPr>
+            <a:r>
+              <a:rPr lang="en-US" sz="920" b="1" dirty="0">
+                <a:solidFill>
+                  <a:srgbClr val="1F5FBF"/>
+                </a:solidFill>
+              </a:rPr>
+              <a:t>종목 상세 / 매수·매도 입력</a:t>
+            </a:r>
+            <a:endParaRPr lang="en-US" sz="920" dirty="0"/>
+          </a:p>
+        </p:txBody>
+      </p:sp>
+      <p:sp>
+        <p:nvSpPr>
+          <p:cNvPr id="11" name="Text 7"/>
+          <p:cNvSpPr/>
+          <p:nvPr/>
+        </p:nvSpPr>
+        <p:spPr>
+          <a:xfrm>
+            <a:off x="9326880" y="1234440"/>
+            <a:ext cx="1920240" cy="960120"/>
+          </a:xfrm>
+          <a:prstGeom prst="rect">
+            <a:avLst/>
+          </a:prstGeom>
+          <a:noFill/>
+          <a:ln/>
+        </p:spPr>
+        <p:txBody>
+          <a:bodyPr wrap="square" lIns="254" tIns="254" rIns="254" bIns="254" rtlCol="0" anchor="ctr">
             <a:normAutofit/>
           </a:bodyPr>
           <a:lstStyle/>
@@ -3865,31 +3976,111 @@
               <a:buNone/>
             </a:pPr>
             <a:r>
-              <a:rPr lang="en-US" sz="1070" dirty="0">
+              <a:rPr lang="en-US" sz="1130" b="1" dirty="0">
                 <a:solidFill>
                   <a:srgbClr val="182230"/>
                 </a:solidFill>
               </a:rPr>
-              <a:t>현금, 평가액, 총자산, 손익, 수익률 표시</a:t>
-            </a:r>
-            <a:endParaRPr lang="en-US" sz="1070" dirty="0"/>
-          </a:p>
-        </p:txBody>
-      </p:sp>
-      <p:sp>
-        <p:nvSpPr>
-          <p:cNvPr id="8" name="Shape 6"/>
-          <p:cNvSpPr/>
-          <p:nvPr/>
-        </p:nvSpPr>
-        <p:spPr>
-          <a:xfrm>
-            <a:off x="3520440" y="914400"/>
-            <a:ext cx="2743200" cy="960120"/>
+              <a:t>검색 결과에서 종목을 누르면</a:t>
+            </a:r>
+            <a:endParaRPr lang="en-US" sz="1130" dirty="0"/>
+          </a:p>
+          <a:p>
+            <a:pPr indent="0" marL="0">
+              <a:buNone/>
+            </a:pPr>
+            <a:r>
+              <a:rPr lang="en-US" sz="1130" b="1" dirty="0">
+                <a:solidFill>
+                  <a:srgbClr val="182230"/>
+                </a:solidFill>
+              </a:rPr>
+              <a:t>상세 정보와 주문 입력이</a:t>
+            </a:r>
+            <a:endParaRPr lang="en-US" sz="1130" dirty="0"/>
+          </a:p>
+          <a:p>
+            <a:pPr indent="0" marL="0">
+              <a:buNone/>
+            </a:pPr>
+            <a:r>
+              <a:rPr lang="en-US" sz="1130" b="1" dirty="0">
+                <a:solidFill>
+                  <a:srgbClr val="182230"/>
+                </a:solidFill>
+              </a:rPr>
+              <a:t>같은 화면에서 이어진다.</a:t>
+            </a:r>
+            <a:endParaRPr lang="en-US" sz="1130" dirty="0"/>
+          </a:p>
+        </p:txBody>
+      </p:sp>
+      <p:sp>
+        <p:nvSpPr>
+          <p:cNvPr id="12" name="Text 8"/>
+          <p:cNvSpPr/>
+          <p:nvPr/>
+        </p:nvSpPr>
+        <p:spPr>
+          <a:xfrm>
+            <a:off x="9326880" y="2487168"/>
+            <a:ext cx="1874520" cy="731520"/>
+          </a:xfrm>
+          <a:prstGeom prst="rect">
+            <a:avLst/>
+          </a:prstGeom>
+          <a:noFill/>
+          <a:ln/>
+        </p:spPr>
+        <p:txBody>
+          <a:bodyPr wrap="square" lIns="254" tIns="254" rIns="254" bIns="254" rtlCol="0" anchor="ctr">
+            <a:normAutofit/>
+          </a:bodyPr>
+          <a:lstStyle/>
+          <a:p>
+            <a:pPr indent="0" marL="0">
+              <a:buNone/>
+            </a:pPr>
+            <a:r>
+              <a:rPr lang="en-US" sz="1020" dirty="0">
+                <a:solidFill>
+                  <a:srgbClr val="667085"/>
+                </a:solidFill>
+              </a:rPr>
+              <a:t>시세 확인 → 수량 입력 → 매수</a:t>
+            </a:r>
+            <a:endParaRPr lang="en-US" sz="1020" dirty="0"/>
+          </a:p>
+          <a:p>
+            <a:pPr indent="0" marL="0">
+              <a:buNone/>
+            </a:pPr>
+            <a:r>
+              <a:rPr lang="en-US" sz="1020" dirty="0">
+                <a:solidFill>
+                  <a:srgbClr val="667085"/>
+                </a:solidFill>
+              </a:rPr>
+              <a:t>보유 종목 기준 매도</a:t>
+            </a:r>
+            <a:endParaRPr lang="en-US" sz="1020" dirty="0"/>
+          </a:p>
+        </p:txBody>
+      </p:sp>
+      <p:sp>
+        <p:nvSpPr>
+          <p:cNvPr id="13" name="Shape 9"/>
+          <p:cNvSpPr/>
+          <p:nvPr/>
+        </p:nvSpPr>
+        <p:spPr>
+          <a:xfrm>
+            <a:off x="3977640" y="4709160"/>
+            <a:ext cx="7635240" cy="987552"/>
           </a:xfrm>
           <a:prstGeom prst="roundRect">
             <a:avLst>
-              <a:gd name="adj" fmla="val 5714"/>
+              <a:gd name="adj" fmla="val 3704"/>
             </a:avLst>
           </a:prstGeom>
           <a:solidFill>
@@ -3903,16 +4094,40 @@
           </a:ln>
         </p:spPr>
       </p:sp>
-      <p:sp>
-        <p:nvSpPr>
-          <p:cNvPr id="9" name="Text 7"/>
-          <p:cNvSpPr/>
-          <p:nvPr/>
-        </p:nvSpPr>
-        <p:spPr>
-          <a:xfrm>
-            <a:off x="3685032" y="1060704"/>
-            <a:ext cx="2414016" cy="237744"/>
+      <p:pic>
+        <p:nvPicPr>
+          <p:cNvPr id="14" name="Image 2" descr="C:\Users\user\Documents\Codex\2026-05-19\100\deliverables\ui-screenshots\ui-crop-03-portfolio.png">    </p:cNvPr>
+          <p:cNvPicPr>
+            <a:picLocks noChangeAspect="1"/>
+          </p:cNvPicPr>
+          <p:nvPr/>
+        </p:nvPicPr>
+        <p:blipFill>
+          <a:blip r:embed="rId3"/>
+          <a:stretch>
+            <a:fillRect/>
+          </a:stretch>
+        </p:blipFill>
+        <p:spPr>
+          <a:xfrm>
+            <a:off x="4096512" y="4828032"/>
+            <a:ext cx="7388352" cy="822960"/>
+          </a:xfrm>
+          <a:prstGeom prst="rect">
+            <a:avLst/>
+          </a:prstGeom>
+        </p:spPr>
+      </p:pic>
+      <p:sp>
+        <p:nvSpPr>
+          <p:cNvPr id="15" name="Text 10"/>
+          <p:cNvSpPr/>
+          <p:nvPr/>
+        </p:nvSpPr>
+        <p:spPr>
+          <a:xfrm>
+            <a:off x="4160520" y="5779008"/>
+            <a:ext cx="7269480" cy="219456"/>
           </a:xfrm>
           <a:prstGeom prst="rect">
             <a:avLst/>
@@ -3924,477 +4139,18 @@
           <a:bodyPr wrap="square" lIns="0" tIns="0" rIns="0" bIns="0" rtlCol="0" anchor="ctr"/>
           <a:lstStyle/>
           <a:p>
-            <a:pPr indent="0" marL="0">
-              <a:buNone/>
-            </a:pPr>
-            <a:r>
-              <a:rPr lang="en-US" sz="1200" b="1" dirty="0">
+            <a:pPr algn="ctr" indent="0" marL="0">
+              <a:buNone/>
+            </a:pPr>
+            <a:r>
+              <a:rPr lang="en-US" sz="920" b="1" dirty="0">
                 <a:solidFill>
                   <a:srgbClr val="1F5FBF"/>
                 </a:solidFill>
               </a:rPr>
-              <a:t>시장 시세</a:t>
-            </a:r>
-            <a:endParaRPr lang="en-US" sz="1200" dirty="0"/>
-          </a:p>
-        </p:txBody>
-      </p:sp>
-      <p:sp>
-        <p:nvSpPr>
-          <p:cNvPr id="10" name="Text 8"/>
-          <p:cNvSpPr/>
-          <p:nvPr/>
-        </p:nvSpPr>
-        <p:spPr>
-          <a:xfrm>
-            <a:off x="3685032" y="1389888"/>
-            <a:ext cx="2414016" cy="365760"/>
-          </a:xfrm>
-          <a:prstGeom prst="rect">
-            <a:avLst/>
-          </a:prstGeom>
-          <a:noFill/>
-          <a:ln/>
-        </p:spPr>
-        <p:txBody>
-          <a:bodyPr wrap="square" lIns="381" tIns="381" rIns="381" bIns="381" rtlCol="0" anchor="ctr">
-            <a:normAutofit/>
-          </a:bodyPr>
-          <a:lstStyle/>
-          <a:p>
-            <a:pPr indent="0" marL="0">
-              <a:buNone/>
-            </a:pPr>
-            <a:r>
-              <a:rPr lang="en-US" sz="1070" dirty="0">
-                <a:solidFill>
-                  <a:srgbClr val="182230"/>
-                </a:solidFill>
-              </a:rPr>
-              <a:t>거래량 상위 종목을 10개씩 페이지로 표시</a:t>
-            </a:r>
-            <a:endParaRPr lang="en-US" sz="1070" dirty="0"/>
-          </a:p>
-        </p:txBody>
-      </p:sp>
-      <p:sp>
-        <p:nvSpPr>
-          <p:cNvPr id="11" name="Shape 9"/>
-          <p:cNvSpPr/>
-          <p:nvPr/>
-        </p:nvSpPr>
-        <p:spPr>
-          <a:xfrm>
-            <a:off x="6446520" y="914400"/>
-            <a:ext cx="2743200" cy="960120"/>
-          </a:xfrm>
-          <a:prstGeom prst="roundRect">
-            <a:avLst>
-              <a:gd name="adj" fmla="val 5714"/>
-            </a:avLst>
-          </a:prstGeom>
-          <a:solidFill>
-            <a:srgbClr val="FFFFFF"/>
-          </a:solidFill>
-          <a:ln w="12700">
-            <a:solidFill>
-              <a:srgbClr val="D7DEEA"/>
-            </a:solidFill>
-            <a:prstDash val="solid"/>
-          </a:ln>
-        </p:spPr>
-      </p:sp>
-      <p:sp>
-        <p:nvSpPr>
-          <p:cNvPr id="12" name="Text 10"/>
-          <p:cNvSpPr/>
-          <p:nvPr/>
-        </p:nvSpPr>
-        <p:spPr>
-          <a:xfrm>
-            <a:off x="6611112" y="1060704"/>
-            <a:ext cx="2414016" cy="237744"/>
-          </a:xfrm>
-          <a:prstGeom prst="rect">
-            <a:avLst/>
-          </a:prstGeom>
-          <a:noFill/>
-          <a:ln/>
-        </p:spPr>
-        <p:txBody>
-          <a:bodyPr wrap="square" lIns="0" tIns="0" rIns="0" bIns="0" rtlCol="0" anchor="ctr"/>
-          <a:lstStyle/>
-          <a:p>
-            <a:pPr indent="0" marL="0">
-              <a:buNone/>
-            </a:pPr>
-            <a:r>
-              <a:rPr lang="en-US" sz="1200" b="1" dirty="0">
-                <a:solidFill>
-                  <a:srgbClr val="1F5FBF"/>
-                </a:solidFill>
-              </a:rPr>
-              <a:t>종목 상세</a:t>
-            </a:r>
-            <a:endParaRPr lang="en-US" sz="1200" dirty="0"/>
-          </a:p>
-        </p:txBody>
-      </p:sp>
-      <p:sp>
-        <p:nvSpPr>
-          <p:cNvPr id="13" name="Text 11"/>
-          <p:cNvSpPr/>
-          <p:nvPr/>
-        </p:nvSpPr>
-        <p:spPr>
-          <a:xfrm>
-            <a:off x="6611112" y="1389888"/>
-            <a:ext cx="2414016" cy="365760"/>
-          </a:xfrm>
-          <a:prstGeom prst="rect">
-            <a:avLst/>
-          </a:prstGeom>
-          <a:noFill/>
-          <a:ln/>
-        </p:spPr>
-        <p:txBody>
-          <a:bodyPr wrap="square" lIns="381" tIns="381" rIns="381" bIns="381" rtlCol="0" anchor="ctr">
-            <a:normAutofit/>
-          </a:bodyPr>
-          <a:lstStyle/>
-          <a:p>
-            <a:pPr indent="0" marL="0">
-              <a:buNone/>
-            </a:pPr>
-            <a:r>
-              <a:rPr lang="en-US" sz="1070" dirty="0">
-                <a:solidFill>
-                  <a:srgbClr val="182230"/>
-                </a:solidFill>
-              </a:rPr>
-              <a:t>현재가, 그래프, 매수 입력</a:t>
-            </a:r>
-            <a:endParaRPr lang="en-US" sz="1070" dirty="0"/>
-          </a:p>
-        </p:txBody>
-      </p:sp>
-      <p:sp>
-        <p:nvSpPr>
-          <p:cNvPr id="14" name="Shape 12"/>
-          <p:cNvSpPr/>
-          <p:nvPr/>
-        </p:nvSpPr>
-        <p:spPr>
-          <a:xfrm>
-            <a:off x="9372600" y="914400"/>
-            <a:ext cx="2194560" cy="960120"/>
-          </a:xfrm>
-          <a:prstGeom prst="roundRect">
-            <a:avLst>
-              <a:gd name="adj" fmla="val 5714"/>
-            </a:avLst>
-          </a:prstGeom>
-          <a:solidFill>
-            <a:srgbClr val="FFFFFF"/>
-          </a:solidFill>
-          <a:ln w="12700">
-            <a:solidFill>
-              <a:srgbClr val="D7DEEA"/>
-            </a:solidFill>
-            <a:prstDash val="solid"/>
-          </a:ln>
-        </p:spPr>
-      </p:sp>
-      <p:sp>
-        <p:nvSpPr>
-          <p:cNvPr id="15" name="Text 13"/>
-          <p:cNvSpPr/>
-          <p:nvPr/>
-        </p:nvSpPr>
-        <p:spPr>
-          <a:xfrm>
-            <a:off x="9537192" y="1060704"/>
-            <a:ext cx="1865376" cy="237744"/>
-          </a:xfrm>
-          <a:prstGeom prst="rect">
-            <a:avLst/>
-          </a:prstGeom>
-          <a:noFill/>
-          <a:ln/>
-        </p:spPr>
-        <p:txBody>
-          <a:bodyPr wrap="square" lIns="0" tIns="0" rIns="0" bIns="0" rtlCol="0" anchor="ctr"/>
-          <a:lstStyle/>
-          <a:p>
-            <a:pPr indent="0" marL="0">
-              <a:buNone/>
-            </a:pPr>
-            <a:r>
-              <a:rPr lang="en-US" sz="1200" b="1" dirty="0">
-                <a:solidFill>
-                  <a:srgbClr val="1F5FBF"/>
-                </a:solidFill>
-              </a:rPr>
-              <a:t>보유 탭</a:t>
-            </a:r>
-            <a:endParaRPr lang="en-US" sz="1200" dirty="0"/>
-          </a:p>
-        </p:txBody>
-      </p:sp>
-      <p:sp>
-        <p:nvSpPr>
-          <p:cNvPr id="16" name="Text 14"/>
-          <p:cNvSpPr/>
-          <p:nvPr/>
-        </p:nvSpPr>
-        <p:spPr>
-          <a:xfrm>
-            <a:off x="9537192" y="1389888"/>
-            <a:ext cx="1865376" cy="365760"/>
-          </a:xfrm>
-          <a:prstGeom prst="rect">
-            <a:avLst/>
-          </a:prstGeom>
-          <a:noFill/>
-          <a:ln/>
-        </p:spPr>
-        <p:txBody>
-          <a:bodyPr wrap="square" lIns="381" tIns="381" rIns="381" bIns="381" rtlCol="0" anchor="ctr">
-            <a:normAutofit/>
-          </a:bodyPr>
-          <a:lstStyle/>
-          <a:p>
-            <a:pPr indent="0" marL="0">
-              <a:buNone/>
-            </a:pPr>
-            <a:r>
-              <a:rPr lang="en-US" sz="1070" dirty="0">
-                <a:solidFill>
-                  <a:srgbClr val="182230"/>
-                </a:solidFill>
-              </a:rPr>
-              <a:t>보유 종목별 매도 수량 입력</a:t>
-            </a:r>
-            <a:endParaRPr lang="en-US" sz="1070" dirty="0"/>
-          </a:p>
-        </p:txBody>
-      </p:sp>
-      <p:sp>
-        <p:nvSpPr>
-          <p:cNvPr id="17" name="Shape 15"/>
-          <p:cNvSpPr/>
-          <p:nvPr/>
-        </p:nvSpPr>
-        <p:spPr>
-          <a:xfrm>
-            <a:off x="640080" y="2423160"/>
-            <a:ext cx="10881360" cy="3017520"/>
-          </a:xfrm>
-          <a:prstGeom prst="rect">
-            <a:avLst/>
-          </a:prstGeom>
-          <a:solidFill>
-            <a:srgbClr val="F6F9FD"/>
-          </a:solidFill>
-          <a:ln w="12700">
-            <a:solidFill>
-              <a:srgbClr val="D7DEEA"/>
-            </a:solidFill>
-            <a:prstDash val="solid"/>
-          </a:ln>
-        </p:spPr>
-      </p:sp>
-      <p:sp>
-        <p:nvSpPr>
-          <p:cNvPr id="18" name="Text 16"/>
-          <p:cNvSpPr/>
-          <p:nvPr/>
-        </p:nvSpPr>
-        <p:spPr>
-          <a:xfrm>
-            <a:off x="914400" y="2697480"/>
-            <a:ext cx="1828800" cy="274320"/>
-          </a:xfrm>
-          <a:prstGeom prst="rect">
-            <a:avLst/>
-          </a:prstGeom>
-          <a:noFill/>
-          <a:ln/>
-        </p:spPr>
-        <p:txBody>
-          <a:bodyPr wrap="square" lIns="0" tIns="0" rIns="0" bIns="0" rtlCol="0" anchor="ctr"/>
-          <a:lstStyle/>
-          <a:p>
-            <a:pPr indent="0" marL="0">
-              <a:buNone/>
-            </a:pPr>
-            <a:r>
-              <a:rPr lang="en-US" sz="1300" b="1" dirty="0">
-                <a:solidFill>
-                  <a:srgbClr val="182230"/>
-                </a:solidFill>
-              </a:rPr>
-              <a:t>시장 시세</a:t>
-            </a:r>
-            <a:endParaRPr lang="en-US" sz="1300" dirty="0"/>
-          </a:p>
-        </p:txBody>
-      </p:sp>
-      <p:sp>
-        <p:nvSpPr>
-          <p:cNvPr id="19" name="Text 17"/>
-          <p:cNvSpPr/>
-          <p:nvPr/>
-        </p:nvSpPr>
-        <p:spPr>
-          <a:xfrm>
-            <a:off x="914400" y="3154680"/>
-            <a:ext cx="4937760" cy="228600"/>
-          </a:xfrm>
-          <a:prstGeom prst="rect">
-            <a:avLst/>
-          </a:prstGeom>
-          <a:noFill/>
-          <a:ln/>
-        </p:spPr>
-        <p:txBody>
-          <a:bodyPr wrap="square" lIns="0" tIns="0" rIns="0" bIns="0" rtlCol="0" anchor="ctr"/>
-          <a:lstStyle/>
-          <a:p>
-            <a:pPr indent="0" marL="0">
-              <a:buNone/>
-            </a:pPr>
-            <a:r>
-              <a:rPr lang="en-US" sz="1100" dirty="0">
-                <a:solidFill>
-                  <a:srgbClr val="667085"/>
-                </a:solidFill>
-              </a:rPr>
-              <a:t>검색창 · 즐겨찾기 · 10개 단위 페이지 · 상세/매수 버튼</a:t>
-            </a:r>
-            <a:endParaRPr lang="en-US" sz="1100" dirty="0"/>
-          </a:p>
-        </p:txBody>
-      </p:sp>
-      <p:sp>
-        <p:nvSpPr>
-          <p:cNvPr id="20" name="Text 18"/>
-          <p:cNvSpPr/>
-          <p:nvPr/>
-        </p:nvSpPr>
-        <p:spPr>
-          <a:xfrm>
-            <a:off x="6400800" y="2697480"/>
-            <a:ext cx="2194560" cy="274320"/>
-          </a:xfrm>
-          <a:prstGeom prst="rect">
-            <a:avLst/>
-          </a:prstGeom>
-          <a:noFill/>
-          <a:ln/>
-        </p:spPr>
-        <p:txBody>
-          <a:bodyPr wrap="square" lIns="0" tIns="0" rIns="0" bIns="0" rtlCol="0" anchor="ctr"/>
-          <a:lstStyle/>
-          <a:p>
-            <a:pPr indent="0" marL="0">
-              <a:buNone/>
-            </a:pPr>
-            <a:r>
-              <a:rPr lang="en-US" sz="1300" b="1" dirty="0">
-                <a:solidFill>
-                  <a:srgbClr val="182230"/>
-                </a:solidFill>
-              </a:rPr>
-              <a:t>종목 상세</a:t>
-            </a:r>
-            <a:endParaRPr lang="en-US" sz="1300" dirty="0"/>
-          </a:p>
-        </p:txBody>
-      </p:sp>
-      <p:sp>
-        <p:nvSpPr>
-          <p:cNvPr id="21" name="Text 19"/>
-          <p:cNvSpPr/>
-          <p:nvPr/>
-        </p:nvSpPr>
-        <p:spPr>
-          <a:xfrm>
-            <a:off x="6400800" y="3154680"/>
-            <a:ext cx="3931920" cy="594360"/>
-          </a:xfrm>
-          <a:prstGeom prst="rect">
-            <a:avLst/>
-          </a:prstGeom>
-          <a:noFill/>
-          <a:ln/>
-        </p:spPr>
-        <p:txBody>
-          <a:bodyPr wrap="square" lIns="0" tIns="0" rIns="0" bIns="0" rtlCol="0" anchor="ctr"/>
-          <a:lstStyle/>
-          <a:p>
-            <a:pPr indent="0" marL="0">
-              <a:buNone/>
-            </a:pPr>
-            <a:r>
-              <a:rPr lang="en-US" sz="1100" dirty="0">
-                <a:solidFill>
-                  <a:srgbClr val="667085"/>
-                </a:solidFill>
-              </a:rPr>
-              <a:t>현재가 · 등락률 · 가격 변화 그래프</a:t>
-            </a:r>
-            <a:endParaRPr lang="en-US" sz="1100" dirty="0"/>
-          </a:p>
-          <a:p>
-            <a:pPr indent="0" marL="0">
-              <a:buNone/>
-            </a:pPr>
-            <a:r>
-              <a:rPr lang="en-US" sz="1100" dirty="0">
-                <a:solidFill>
-                  <a:srgbClr val="667085"/>
-                </a:solidFill>
-              </a:rPr>
-              <a:t>매수 수량 입력 → 매수</a:t>
-            </a:r>
-            <a:endParaRPr lang="en-US" sz="1100" dirty="0"/>
-          </a:p>
-        </p:txBody>
-      </p:sp>
-      <p:sp>
-        <p:nvSpPr>
-          <p:cNvPr id="22" name="Text 20"/>
-          <p:cNvSpPr/>
-          <p:nvPr/>
-        </p:nvSpPr>
-        <p:spPr>
-          <a:xfrm>
-            <a:off x="914400" y="5074920"/>
-            <a:ext cx="10058400" cy="320040"/>
-          </a:xfrm>
-          <a:prstGeom prst="rect">
-            <a:avLst/>
-          </a:prstGeom>
-          <a:noFill/>
-          <a:ln/>
-        </p:spPr>
-        <p:txBody>
-          <a:bodyPr wrap="square" lIns="0" tIns="0" rIns="0" bIns="0" rtlCol="0" anchor="ctr"/>
-          <a:lstStyle/>
-          <a:p>
-            <a:pPr indent="0" marL="0">
-              <a:buNone/>
-            </a:pPr>
-            <a:r>
-              <a:rPr lang="en-US" sz="1250" b="1" dirty="0">
-                <a:solidFill>
-                  <a:srgbClr val="1F5FBF"/>
-                </a:solidFill>
-              </a:rPr>
-              <a:t>최종 화면은 실제 증권 웹앱처럼 흰 배경, 표 중심 구성, 상승 빨강/하락 파랑 색상 체계를 적용했다.</a:t>
-            </a:r>
-            <a:endParaRPr lang="en-US" sz="1250" dirty="0"/>
+              <a:t>보유 종목 / 평가금액 / 손익률</a:t>
+            </a:r>
+            <a:endParaRPr lang="en-US" sz="920" dirty="0"/>
           </a:p>
         </p:txBody>
       </p:sp>
@@ -8974,33 +8730,9 @@
           </a:p>
         </p:txBody>
       </p:sp>
-      <p:pic>
-        <p:nvPicPr>
-          <p:cNvPr id="35" name="Image 0" descr="C:\Users\user\Documents\Codex\2026-05-19\100\deliverables\mock-stock-website-demo-preview.png">    </p:cNvPr>
-          <p:cNvPicPr>
-            <a:picLocks noChangeAspect="1"/>
-          </p:cNvPicPr>
-          <p:nvPr/>
-        </p:nvPicPr>
-        <p:blipFill>
-          <a:blip r:embed="rId1"/>
-          <a:stretch>
-            <a:fillRect/>
-          </a:stretch>
-        </p:blipFill>
-        <p:spPr>
-          <a:xfrm>
-            <a:off x="7315200" y="914400"/>
-            <a:ext cx="4297680" cy="2423160"/>
-          </a:xfrm>
-          <a:prstGeom prst="rect">
-            <a:avLst/>
-          </a:prstGeom>
-        </p:spPr>
-      </p:pic>
-      <p:sp>
-        <p:nvSpPr>
-          <p:cNvPr id="36" name="Text 33"/>
+      <p:sp>
+        <p:nvSpPr>
+          <p:cNvPr id="35" name="Text 33"/>
           <p:cNvSpPr/>
           <p:nvPr/>
         </p:nvSpPr>
@@ -9036,7 +8768,7 @@
       </p:sp>
       <p:sp>
         <p:nvSpPr>
-          <p:cNvPr id="37" name="Text 34"/>
+          <p:cNvPr id="36" name="Text 34"/>
           <p:cNvSpPr/>
           <p:nvPr/>
         </p:nvSpPr>

</xml_diff>